<commit_message>
Section6b (Frontier models) PPTX: hand-tuned 7-slide build matching HTML — divider opener, primer slides w/ cyan-number chips, fall-short bar chart (transparent) + hallucination taxonomy figure, bitter-lesson & this-room turns w/ amber left-bars
</commit_message>
<xml_diff>
--- a/keynote-iwbi-2026/pptx/sections/IWBI2026_Trivedi_06b_frontier.pptx
+++ b/keynote-iwbi-2026/pptx/sections/IWBI2026_Trivedi_06b_frontier.pptx
@@ -3942,16 +3942,40 @@
         <p:nvPr/>
       </p:nvGrpSpPr>
       <p:grpSpPr/>
-      <p:sp>
-        <p:nvSpPr>
-          <p:cNvPr id="2" name="Rectangle 1"/>
+      <p:pic>
+        <p:nvPicPr>
+          <p:cNvPr id="2" name="Picture 1" descr="bg_motif.png"/>
+          <p:cNvPicPr>
+            <a:picLocks noChangeAspect="1"/>
+          </p:cNvPicPr>
+          <p:nvPr/>
+        </p:nvPicPr>
+        <p:blipFill>
+          <a:blip r:embed="rId2"/>
+          <a:stretch>
+            <a:fillRect/>
+          </a:stretch>
+        </p:blipFill>
+        <p:spPr>
+          <a:xfrm>
+            <a:off x="0" y="0"/>
+            <a:ext cx="12191695" cy="6858000"/>
+          </a:xfrm>
+          <a:prstGeom prst="rect">
+            <a:avLst/>
+          </a:prstGeom>
+        </p:spPr>
+      </p:pic>
+      <p:sp>
+        <p:nvSpPr>
+          <p:cNvPr id="3" name="Rectangle 2"/>
           <p:cNvSpPr/>
           <p:nvPr/>
         </p:nvSpPr>
         <p:spPr>
           <a:xfrm>
             <a:off x="0" y="0"/>
-            <a:ext cx="12191695" cy="38100"/>
+            <a:ext cx="5486400" cy="38100"/>
           </a:xfrm>
           <a:prstGeom prst="rect">
             <a:avLst/>
@@ -3988,14 +4012,14 @@
       </p:sp>
       <p:sp>
         <p:nvSpPr>
-          <p:cNvPr id="3" name="TextBox 2"/>
+          <p:cNvPr id="4" name="TextBox 3"/>
           <p:cNvSpPr txBox="1"/>
           <p:nvPr/>
         </p:nvSpPr>
         <p:spPr>
           <a:xfrm>
-            <a:off x="777240" y="2443480"/>
-            <a:ext cx="10607040" cy="346456"/>
+            <a:off x="777240" y="2103120"/>
+            <a:ext cx="8229600" cy="310896"/>
           </a:xfrm>
           <a:prstGeom prst="rect">
             <a:avLst/>
@@ -4003,77 +4027,65 @@
           <a:noFill/>
         </p:spPr>
         <p:txBody>
-          <a:bodyPr wrap="square" lIns="25400" rIns="25400" tIns="12700" bIns="12700">
-            <a:noAutofit/>
+          <a:bodyPr wrap="square" anchor="t" lIns="0" rIns="0" tIns="0" bIns="0">
+            <a:spAutoFit/>
           </a:bodyPr>
           <a:lstStyle/>
           <a:p>
             <a:pPr algn="l">
               <a:lnSpc>
-                <a:spcPct val="128000"/>
+                <a:spcPct val="100000"/>
               </a:lnSpc>
-              <a:spcAft>
-                <a:spcPts val="400"/>
-              </a:spcAft>
             </a:pPr>
             <a:r>
-              <a:rPr sz="1400" b="0">
-                <a:solidFill>
-                  <a:srgbClr val="9DA9B5"/>
-                </a:solidFill>
-                <a:latin typeface="Arial"/>
-              </a:rPr>
-              <a:t>Specialist</a:t>
-            </a:r>
-            <a:r>
-              <a:rPr sz="1400" b="0">
-                <a:solidFill>
-                  <a:srgbClr val="9DA9B5"/>
-                </a:solidFill>
-                <a:latin typeface="Arial"/>
-              </a:rPr>
-              <a:t>vs</a:t>
-            </a:r>
-            <a:r>
-              <a:rPr sz="1400" b="0">
-                <a:solidFill>
-                  <a:srgbClr val="9DA9B5"/>
-                </a:solidFill>
-                <a:latin typeface="Arial"/>
-              </a:rPr>
-              <a:t>Generalist</a:t>
-            </a:r>
-            <a:r>
-              <a:rPr sz="1400" b="0">
-                <a:solidFill>
-                  <a:srgbClr val="9DA9B5"/>
-                </a:solidFill>
-                <a:latin typeface="Arial"/>
-              </a:rPr>
-              <a:t>·</a:t>
-            </a:r>
-            <a:r>
-              <a:rPr sz="1400" b="0">
-                <a:solidFill>
-                  <a:srgbClr val="9DA9B5"/>
-                </a:solidFill>
-                <a:latin typeface="Arial"/>
-              </a:rPr>
-              <a:t>an open question</a:t>
-            </a:r>
-          </a:p>
-        </p:txBody>
-      </p:sp>
-      <p:sp>
-        <p:nvSpPr>
-          <p:cNvPr id="4" name="TextBox 3"/>
+              <a:rPr sz="1100" b="0" i="0">
+                <a:solidFill>
+                  <a:srgbClr val="5C6975"/>
+                </a:solidFill>
+                <a:latin typeface="Consolas"/>
+              </a:rPr>
+              <a:t>SPECIALIST </a:t>
+            </a:r>
+            <a:r>
+              <a:rPr sz="1100" b="0" i="0">
+                <a:solidFill>
+                  <a:srgbClr val="5C6975"/>
+                </a:solidFill>
+                <a:latin typeface="Consolas"/>
+              </a:rPr>
+              <a:t>vs </a:t>
+            </a:r>
+            <a:r>
+              <a:rPr sz="1100" b="1" i="0">
+                <a:solidFill>
+                  <a:srgbClr val="E7AC51"/>
+                </a:solidFill>
+                <a:latin typeface="Consolas"/>
+              </a:rPr>
+              <a:t>GENERALIST</a:t>
+            </a:r>
+            <a:r>
+              <a:rPr sz="1100" b="0" i="0">
+                <a:solidFill>
+                  <a:srgbClr val="5C6975"/>
+                </a:solidFill>
+                <a:latin typeface="Consolas"/>
+              </a:rPr>
+              <a:t> · AN OPEN QUESTION</a:t>
+            </a:r>
+          </a:p>
+        </p:txBody>
+      </p:sp>
+      <p:sp>
+        <p:nvSpPr>
+          <p:cNvPr id="5" name="TextBox 4"/>
           <p:cNvSpPr txBox="1"/>
           <p:nvPr/>
         </p:nvSpPr>
         <p:spPr>
           <a:xfrm>
-            <a:off x="777240" y="2789936"/>
-            <a:ext cx="10607040" cy="1416303"/>
+            <a:off x="777240" y="2514600"/>
+            <a:ext cx="9601200" cy="1554480"/>
           </a:xfrm>
           <a:prstGeom prst="rect">
             <a:avLst/>
@@ -4081,21 +4093,18 @@
           <a:noFill/>
         </p:spPr>
         <p:txBody>
-          <a:bodyPr wrap="square" lIns="25400" rIns="25400" tIns="12700" bIns="12700">
-            <a:noAutofit/>
+          <a:bodyPr wrap="square" anchor="t" lIns="0" rIns="0" tIns="0" bIns="0">
+            <a:spAutoFit/>
           </a:bodyPr>
           <a:lstStyle/>
           <a:p>
             <a:pPr algn="l">
               <a:lnSpc>
-                <a:spcPct val="106000"/>
+                <a:spcPct val="105000"/>
               </a:lnSpc>
-              <a:spcAft>
-                <a:spcPts val="400"/>
-              </a:spcAft>
             </a:pPr>
             <a:r>
-              <a:rPr sz="4400" b="0">
+              <a:rPr sz="4400" b="1" i="0">
                 <a:solidFill>
                   <a:srgbClr val="ECEFF3"/>
                 </a:solidFill>
@@ -4104,7 +4113,7 @@
               <a:t>Will the generalists </a:t>
             </a:r>
             <a:r>
-              <a:rPr sz="4400" b="0">
+              <a:rPr sz="4400" b="1" i="0">
                 <a:solidFill>
                   <a:srgbClr val="E7AC51"/>
                 </a:solidFill>
@@ -4117,14 +4126,14 @@
       </p:sp>
       <p:sp>
         <p:nvSpPr>
-          <p:cNvPr id="5" name="TextBox 4"/>
+          <p:cNvPr id="6" name="TextBox 5"/>
           <p:cNvSpPr txBox="1"/>
           <p:nvPr/>
         </p:nvSpPr>
         <p:spPr>
           <a:xfrm>
-            <a:off x="777240" y="4206240"/>
-            <a:ext cx="10607040" cy="574040"/>
+            <a:off x="777240" y="4251960"/>
+            <a:ext cx="9875520" cy="1463040"/>
           </a:xfrm>
           <a:prstGeom prst="rect">
             <a:avLst/>
@@ -4132,21 +4141,18 @@
           <a:noFill/>
         </p:spPr>
         <p:txBody>
-          <a:bodyPr wrap="square" lIns="25400" rIns="25400" tIns="12700" bIns="12700">
-            <a:noAutofit/>
+          <a:bodyPr wrap="square" anchor="t" lIns="0" rIns="0" tIns="0" bIns="0">
+            <a:spAutoFit/>
           </a:bodyPr>
           <a:lstStyle/>
           <a:p>
             <a:pPr algn="l">
               <a:lnSpc>
-                <a:spcPct val="128000"/>
+                <a:spcPct val="145000"/>
               </a:lnSpc>
-              <a:spcAft>
-                <a:spcPts val="400"/>
-              </a:spcAft>
             </a:pPr>
             <a:r>
-              <a:rPr sz="1400" b="0">
+              <a:rPr sz="1700" b="0" i="0">
                 <a:solidFill>
                   <a:srgbClr val="9DA9B5"/>
                 </a:solidFill>
@@ -4155,7 +4161,7 @@
               <a:t>Every model in this talk was </a:t>
             </a:r>
             <a:r>
-              <a:rPr sz="1400" b="1">
+              <a:rPr sz="1700" b="1" i="0">
                 <a:solidFill>
                   <a:srgbClr val="ECEFF3"/>
                 </a:solidFill>
@@ -4164,7 +4170,7 @@
               <a:t>purpose-built.</a:t>
             </a:r>
             <a:r>
-              <a:rPr sz="1400" b="0">
+              <a:rPr sz="1700" b="0" i="0">
                 <a:solidFill>
                   <a:srgbClr val="9DA9B5"/>
                 </a:solidFill>
@@ -4173,7 +4179,7 @@
               <a:t> The frontier models from OpenAI, Google, and Anthropic were not built for medicine — yet they improve every few months. </a:t>
             </a:r>
             <a:r>
-              <a:rPr sz="1400" b="1">
+              <a:rPr sz="1700" b="1" i="0">
                 <a:solidFill>
                   <a:srgbClr val="ECEFF3"/>
                 </a:solidFill>
@@ -4210,16 +4216,40 @@
         <p:nvPr/>
       </p:nvGrpSpPr>
       <p:grpSpPr/>
-      <p:sp>
-        <p:nvSpPr>
-          <p:cNvPr id="2" name="Rectangle 1"/>
+      <p:pic>
+        <p:nvPicPr>
+          <p:cNvPr id="2" name="Picture 1" descr="bg_motif.png"/>
+          <p:cNvPicPr>
+            <a:picLocks noChangeAspect="1"/>
+          </p:cNvPicPr>
+          <p:nvPr/>
+        </p:nvPicPr>
+        <p:blipFill>
+          <a:blip r:embed="rId2"/>
+          <a:stretch>
+            <a:fillRect/>
+          </a:stretch>
+        </p:blipFill>
+        <p:spPr>
+          <a:xfrm>
+            <a:off x="0" y="0"/>
+            <a:ext cx="12191695" cy="6858000"/>
+          </a:xfrm>
+          <a:prstGeom prst="rect">
+            <a:avLst/>
+          </a:prstGeom>
+        </p:spPr>
+      </p:pic>
+      <p:sp>
+        <p:nvSpPr>
+          <p:cNvPr id="3" name="Rectangle 2"/>
           <p:cNvSpPr/>
           <p:nvPr/>
         </p:nvSpPr>
         <p:spPr>
           <a:xfrm>
             <a:off x="0" y="0"/>
-            <a:ext cx="12191695" cy="38100"/>
+            <a:ext cx="5486400" cy="38100"/>
           </a:xfrm>
           <a:prstGeom prst="rect">
             <a:avLst/>
@@ -4256,14 +4286,14 @@
       </p:sp>
       <p:sp>
         <p:nvSpPr>
-          <p:cNvPr id="3" name="TextBox 2"/>
+          <p:cNvPr id="4" name="TextBox 3"/>
           <p:cNvSpPr txBox="1"/>
           <p:nvPr/>
         </p:nvSpPr>
         <p:spPr>
           <a:xfrm>
-            <a:off x="777240" y="411480"/>
-            <a:ext cx="8686800" cy="365760"/>
+            <a:off x="777240" y="502920"/>
+            <a:ext cx="8229600" cy="320040"/>
           </a:xfrm>
           <a:prstGeom prst="rect">
             <a:avLst/>
@@ -4271,21 +4301,18 @@
           <a:noFill/>
         </p:spPr>
         <p:txBody>
-          <a:bodyPr wrap="square" lIns="25400" rIns="25400" tIns="12700" bIns="12700">
-            <a:noAutofit/>
+          <a:bodyPr wrap="square" anchor="t" lIns="0" rIns="0" tIns="0" bIns="0">
+            <a:spAutoFit/>
           </a:bodyPr>
           <a:lstStyle/>
           <a:p>
             <a:pPr algn="l">
               <a:lnSpc>
-                <a:spcPct val="128000"/>
+                <a:spcPct val="100000"/>
               </a:lnSpc>
-              <a:spcAft>
-                <a:spcPts val="400"/>
-              </a:spcAft>
             </a:pPr>
             <a:r>
-              <a:rPr sz="1100" b="1">
+              <a:rPr sz="1100" b="1" i="0">
                 <a:solidFill>
                   <a:srgbClr val="E7AC51"/>
                 </a:solidFill>
@@ -4298,14 +4325,14 @@
       </p:sp>
       <p:sp>
         <p:nvSpPr>
-          <p:cNvPr id="4" name="TextBox 3"/>
+          <p:cNvPr id="5" name="TextBox 4"/>
           <p:cNvSpPr txBox="1"/>
           <p:nvPr/>
         </p:nvSpPr>
         <p:spPr>
           <a:xfrm>
-            <a:off x="777240" y="2495550"/>
-            <a:ext cx="10607040" cy="534416"/>
+            <a:off x="777240" y="1234440"/>
+            <a:ext cx="10058400" cy="1280160"/>
           </a:xfrm>
           <a:prstGeom prst="rect">
             <a:avLst/>
@@ -4313,21 +4340,18 @@
           <a:noFill/>
         </p:spPr>
         <p:txBody>
-          <a:bodyPr wrap="square" lIns="25400" rIns="25400" tIns="12700" bIns="12700">
-            <a:noAutofit/>
+          <a:bodyPr wrap="square" anchor="t" lIns="0" rIns="0" tIns="0" bIns="0">
+            <a:spAutoFit/>
           </a:bodyPr>
           <a:lstStyle/>
           <a:p>
             <a:pPr algn="l">
               <a:lnSpc>
-                <a:spcPct val="106000"/>
+                <a:spcPct val="112000"/>
               </a:lnSpc>
-              <a:spcAft>
-                <a:spcPts val="400"/>
-              </a:spcAft>
             </a:pPr>
             <a:r>
-              <a:rPr sz="2600" b="0">
+              <a:rPr sz="2700" b="1" i="0">
                 <a:solidFill>
                   <a:srgbClr val="ECEFF3"/>
                 </a:solidFill>
@@ -4336,7 +4360,7 @@
               <a:t>Where the generalists </a:t>
             </a:r>
             <a:r>
-              <a:rPr sz="2600" b="0">
+              <a:rPr sz="2700" b="1" i="0">
                 <a:solidFill>
                   <a:srgbClr val="E7AC51"/>
                 </a:solidFill>
@@ -4349,14 +4373,14 @@
       </p:sp>
       <p:sp>
         <p:nvSpPr>
-          <p:cNvPr id="5" name="TextBox 4"/>
+          <p:cNvPr id="6" name="TextBox 5"/>
           <p:cNvSpPr txBox="1"/>
           <p:nvPr/>
         </p:nvSpPr>
         <p:spPr>
           <a:xfrm>
-            <a:off x="777240" y="3029966"/>
-            <a:ext cx="10607040" cy="801623"/>
+            <a:off x="777240" y="2468880"/>
+            <a:ext cx="10424160" cy="1463040"/>
           </a:xfrm>
           <a:prstGeom prst="rect">
             <a:avLst/>
@@ -4364,21 +4388,18 @@
           <a:noFill/>
         </p:spPr>
         <p:txBody>
-          <a:bodyPr wrap="square" lIns="25400" rIns="25400" tIns="12700" bIns="12700">
-            <a:noAutofit/>
+          <a:bodyPr wrap="square" anchor="t" lIns="0" rIns="0" tIns="0" bIns="0">
+            <a:spAutoFit/>
           </a:bodyPr>
           <a:lstStyle/>
           <a:p>
             <a:pPr algn="l">
               <a:lnSpc>
-                <a:spcPct val="128000"/>
+                <a:spcPct val="145000"/>
               </a:lnSpc>
-              <a:spcAft>
-                <a:spcPts val="400"/>
-              </a:spcAft>
             </a:pPr>
             <a:r>
-              <a:rPr sz="1400" b="1">
+              <a:rPr sz="1500" b="1" i="0">
                 <a:solidFill>
                   <a:srgbClr val="ECEFF3"/>
                 </a:solidFill>
@@ -4387,7 +4408,7 @@
               <a:t>Medical knowledge:</a:t>
             </a:r>
             <a:r>
-              <a:rPr sz="1400" b="0">
+              <a:rPr sz="1500" b="0" i="0">
                 <a:solidFill>
                   <a:srgbClr val="9DA9B5"/>
                 </a:solidFill>
@@ -4396,7 +4417,7 @@
               <a:t> frontier models score </a:t>
             </a:r>
             <a:r>
-              <a:rPr sz="1400" b="1">
+              <a:rPr sz="1500" b="1" i="0">
                 <a:solidFill>
                   <a:srgbClr val="ECEFF3"/>
                 </a:solidFill>
@@ -4405,7 +4426,7 @@
               <a:t>~90%+ on USMLE-style exams</a:t>
             </a:r>
             <a:r>
-              <a:rPr sz="1400" b="0">
+              <a:rPr sz="1500" b="0" i="0">
                 <a:solidFill>
                   <a:srgbClr val="9DA9B5"/>
                 </a:solidFill>
@@ -4414,7 +4435,7 @@
               <a:t> (Med-Gemini 91.1%), across the breadth of medicine. </a:t>
             </a:r>
             <a:r>
-              <a:rPr sz="1400" b="1">
+              <a:rPr sz="1500" b="1" i="0">
                 <a:solidFill>
                   <a:srgbClr val="ECEFF3"/>
                 </a:solidFill>
@@ -4423,7 +4444,7 @@
               <a:t>Rapid adaptation:</a:t>
             </a:r>
             <a:r>
-              <a:rPr sz="1400" b="0">
+              <a:rPr sz="1500" b="0" i="0">
                 <a:solidFill>
                   <a:srgbClr val="9DA9B5"/>
                 </a:solidFill>
@@ -4436,14 +4457,14 @@
       </p:sp>
       <p:sp>
         <p:nvSpPr>
-          <p:cNvPr id="6" name="Rounded Rectangle 5"/>
+          <p:cNvPr id="7" name="Rounded Rectangle 6"/>
           <p:cNvSpPr/>
           <p:nvPr/>
         </p:nvSpPr>
         <p:spPr>
           <a:xfrm>
-            <a:off x="777240" y="3831590"/>
-            <a:ext cx="2835020" cy="365760"/>
+            <a:off x="777240" y="4114800"/>
+            <a:ext cx="2745943" cy="384048"/>
           </a:xfrm>
           <a:prstGeom prst="roundRect">
             <a:avLst/>
@@ -4453,7 +4474,7 @@
           </a:solidFill>
           <a:ln w="9525">
             <a:solidFill>
-              <a:srgbClr val="2A333E"/>
+              <a:srgbClr val="2A333D"/>
             </a:solidFill>
           </a:ln>
           <a:effectLst/>
@@ -4473,12 +4494,16 @@
           </a:fontRef>
         </p:style>
         <p:txBody>
-          <a:bodyPr rtlCol="0" anchor="ctr" wrap="none" lIns="109728" rIns="73152" tIns="0" bIns="0"/>
-          <a:lstStyle/>
-          <a:p>
-            <a:pPr algn="ctr"/>
-            <a:r>
-              <a:rPr sz="1100">
+          <a:bodyPr rtlCol="0" anchor="ctr" wrap="none" lIns="137160" tIns="0" bIns="0"/>
+          <a:lstStyle/>
+          <a:p>
+            <a:pPr algn="l">
+              <a:lnSpc>
+                <a:spcPct val="100000"/>
+              </a:lnSpc>
+            </a:pPr>
+            <a:r>
+              <a:rPr sz="1050" b="0" i="0">
                 <a:solidFill>
                   <a:srgbClr val="ECEFF3"/>
                 </a:solidFill>
@@ -4487,21 +4512,21 @@
               <a:t>USMLE-style: </a:t>
             </a:r>
             <a:r>
-              <a:rPr sz="1100">
+              <a:rPr sz="1050" b="1" i="0">
+                <a:solidFill>
+                  <a:srgbClr val="5FB7C9"/>
+                </a:solidFill>
+                <a:latin typeface="Consolas"/>
+              </a:rPr>
+              <a:t>~91%</a:t>
+            </a:r>
+            <a:r>
+              <a:rPr sz="1050" b="0" i="0">
                 <a:solidFill>
                   <a:srgbClr val="ECEFF3"/>
                 </a:solidFill>
                 <a:latin typeface="Consolas"/>
               </a:rPr>
-              <a:t>~91%</a:t>
-            </a:r>
-            <a:r>
-              <a:rPr sz="1100">
-                <a:solidFill>
-                  <a:srgbClr val="ECEFF3"/>
-                </a:solidFill>
-                <a:latin typeface="Consolas"/>
-              </a:rPr>
               <a:t> (Med-Gemini)</a:t>
             </a:r>
           </a:p>
@@ -4509,14 +4534,14 @@
       </p:sp>
       <p:sp>
         <p:nvSpPr>
-          <p:cNvPr id="7" name="Rectangle 6"/>
+          <p:cNvPr id="8" name="Rectangle 7"/>
           <p:cNvSpPr/>
           <p:nvPr/>
         </p:nvSpPr>
         <p:spPr>
           <a:xfrm>
-            <a:off x="777240" y="3831590"/>
-            <a:ext cx="36576" cy="365760"/>
+            <a:off x="777240" y="4114800"/>
+            <a:ext cx="41148" cy="384048"/>
           </a:xfrm>
           <a:prstGeom prst="rect">
             <a:avLst/>
@@ -4553,14 +4578,14 @@
       </p:sp>
       <p:sp>
         <p:nvSpPr>
-          <p:cNvPr id="8" name="Rounded Rectangle 7"/>
+          <p:cNvPr id="9" name="Rounded Rectangle 8"/>
           <p:cNvSpPr/>
           <p:nvPr/>
         </p:nvSpPr>
         <p:spPr>
           <a:xfrm>
-            <a:off x="3703700" y="3831590"/>
-            <a:ext cx="5022596" cy="365760"/>
+            <a:off x="3669487" y="4114800"/>
+            <a:ext cx="4792919" cy="384048"/>
           </a:xfrm>
           <a:prstGeom prst="roundRect">
             <a:avLst/>
@@ -4570,7 +4595,7 @@
           </a:solidFill>
           <a:ln w="9525">
             <a:solidFill>
-              <a:srgbClr val="2A333E"/>
+              <a:srgbClr val="2A333D"/>
             </a:solidFill>
           </a:ln>
           <a:effectLst/>
@@ -4590,12 +4615,16 @@
           </a:fontRef>
         </p:style>
         <p:txBody>
-          <a:bodyPr rtlCol="0" anchor="ctr" wrap="none" lIns="109728" rIns="73152" tIns="0" bIns="0"/>
-          <a:lstStyle/>
-          <a:p>
-            <a:pPr algn="ctr"/>
-            <a:r>
-              <a:rPr sz="1100">
+          <a:bodyPr rtlCol="0" anchor="ctr" wrap="none" lIns="137160" tIns="0" bIns="0"/>
+          <a:lstStyle/>
+          <a:p>
+            <a:pPr algn="l">
+              <a:lnSpc>
+                <a:spcPct val="100000"/>
+              </a:lnSpc>
+            </a:pPr>
+            <a:r>
+              <a:rPr sz="1050" b="0" i="0">
                 <a:solidFill>
                   <a:srgbClr val="ECEFF3"/>
                 </a:solidFill>
@@ -4604,39 +4633,39 @@
               <a:t>2D CXR reports </a:t>
             </a:r>
             <a:r>
-              <a:rPr sz="1100">
+              <a:rPr sz="1050" b="1" i="0">
+                <a:solidFill>
+                  <a:srgbClr val="5FB7C9"/>
+                </a:solidFill>
+                <a:latin typeface="Consolas"/>
+              </a:rPr>
+              <a:t>"equivalent or better"</a:t>
+            </a:r>
+            <a:r>
+              <a:rPr sz="1050" b="0" i="0">
                 <a:solidFill>
                   <a:srgbClr val="ECEFF3"/>
                 </a:solidFill>
                 <a:latin typeface="Consolas"/>
               </a:rPr>
-              <a:t>"equivalent or better"</a:t>
-            </a:r>
-            <a:r>
-              <a:rPr sz="1100">
+              <a:t> in </a:t>
+            </a:r>
+            <a:r>
+              <a:rPr sz="1050" b="1" i="0">
+                <a:solidFill>
+                  <a:srgbClr val="5FB7C9"/>
+                </a:solidFill>
+                <a:latin typeface="Consolas"/>
+              </a:rPr>
+              <a:t>43–96%</a:t>
+            </a:r>
+            <a:r>
+              <a:rPr sz="1050" b="0" i="0">
                 <a:solidFill>
                   <a:srgbClr val="ECEFF3"/>
                 </a:solidFill>
                 <a:latin typeface="Consolas"/>
               </a:rPr>
-              <a:t> in </a:t>
-            </a:r>
-            <a:r>
-              <a:rPr sz="1100">
-                <a:solidFill>
-                  <a:srgbClr val="ECEFF3"/>
-                </a:solidFill>
-                <a:latin typeface="Consolas"/>
-              </a:rPr>
-              <a:t>43–96%</a:t>
-            </a:r>
-            <a:r>
-              <a:rPr sz="1100">
-                <a:solidFill>
-                  <a:srgbClr val="ECEFF3"/>
-                </a:solidFill>
-                <a:latin typeface="Consolas"/>
-              </a:rPr>
               <a:t> of cases</a:t>
             </a:r>
           </a:p>
@@ -4644,14 +4673,14 @@
       </p:sp>
       <p:sp>
         <p:nvSpPr>
-          <p:cNvPr id="9" name="Rectangle 8"/>
+          <p:cNvPr id="10" name="Rectangle 9"/>
           <p:cNvSpPr/>
           <p:nvPr/>
         </p:nvSpPr>
         <p:spPr>
           <a:xfrm>
-            <a:off x="3703700" y="3831590"/>
-            <a:ext cx="36576" cy="365760"/>
+            <a:off x="3669487" y="4114800"/>
+            <a:ext cx="41148" cy="384048"/>
           </a:xfrm>
           <a:prstGeom prst="rect">
             <a:avLst/>
@@ -4688,14 +4717,14 @@
       </p:sp>
       <p:sp>
         <p:nvSpPr>
-          <p:cNvPr id="10" name="Rounded Rectangle 9"/>
+          <p:cNvPr id="11" name="Rounded Rectangle 10"/>
           <p:cNvSpPr/>
           <p:nvPr/>
         </p:nvSpPr>
         <p:spPr>
           <a:xfrm>
-            <a:off x="777240" y="4270502"/>
-            <a:ext cx="3508121" cy="365760"/>
+            <a:off x="777240" y="4626864"/>
+            <a:ext cx="3375781" cy="384048"/>
           </a:xfrm>
           <a:prstGeom prst="roundRect">
             <a:avLst/>
@@ -4705,7 +4734,7 @@
           </a:solidFill>
           <a:ln w="9525">
             <a:solidFill>
-              <a:srgbClr val="2A333E"/>
+              <a:srgbClr val="2A333D"/>
             </a:solidFill>
           </a:ln>
           <a:effectLst/>
@@ -4725,12 +4754,16 @@
           </a:fontRef>
         </p:style>
         <p:txBody>
-          <a:bodyPr rtlCol="0" anchor="ctr" wrap="none" lIns="109728" rIns="73152" tIns="0" bIns="0"/>
-          <a:lstStyle/>
-          <a:p>
-            <a:pPr algn="ctr"/>
-            <a:r>
-              <a:rPr sz="1100">
+          <a:bodyPr rtlCol="0" anchor="ctr" wrap="none" lIns="137160" tIns="0" bIns="0"/>
+          <a:lstStyle/>
+          <a:p>
+            <a:pPr algn="l">
+              <a:lnSpc>
+                <a:spcPct val="100000"/>
+              </a:lnSpc>
+            </a:pPr>
+            <a:r>
+              <a:rPr sz="1050" b="0" i="0">
                 <a:solidFill>
                   <a:srgbClr val="ECEFF3"/>
                 </a:solidFill>
@@ -4739,21 +4772,21 @@
               <a:t>exceeded prior SOTA on </a:t>
             </a:r>
             <a:r>
-              <a:rPr sz="1100">
+              <a:rPr sz="1050" b="1" i="0">
+                <a:solidFill>
+                  <a:srgbClr val="5FB7C9"/>
+                </a:solidFill>
+                <a:latin typeface="Consolas"/>
+              </a:rPr>
+              <a:t>17/20</a:t>
+            </a:r>
+            <a:r>
+              <a:rPr sz="1050" b="0" i="0">
                 <a:solidFill>
                   <a:srgbClr val="ECEFF3"/>
                 </a:solidFill>
                 <a:latin typeface="Consolas"/>
               </a:rPr>
-              <a:t>17/20</a:t>
-            </a:r>
-            <a:r>
-              <a:rPr sz="1100">
-                <a:solidFill>
-                  <a:srgbClr val="ECEFF3"/>
-                </a:solidFill>
-                <a:latin typeface="Consolas"/>
-              </a:rPr>
               <a:t> CXR tasks</a:t>
             </a:r>
           </a:p>
@@ -4761,14 +4794,14 @@
       </p:sp>
       <p:sp>
         <p:nvSpPr>
-          <p:cNvPr id="11" name="Rectangle 10"/>
+          <p:cNvPr id="12" name="Rectangle 11"/>
           <p:cNvSpPr/>
           <p:nvPr/>
         </p:nvSpPr>
         <p:spPr>
           <a:xfrm>
-            <a:off x="777240" y="4270502"/>
-            <a:ext cx="36576" cy="365760"/>
+            <a:off x="777240" y="4626864"/>
+            <a:ext cx="41148" cy="384048"/>
           </a:xfrm>
           <a:prstGeom prst="rect">
             <a:avLst/>
@@ -4805,14 +4838,14 @@
       </p:sp>
       <p:sp>
         <p:nvSpPr>
-          <p:cNvPr id="12" name="TextBox 11"/>
+          <p:cNvPr id="13" name="TextBox 12"/>
           <p:cNvSpPr txBox="1"/>
           <p:nvPr/>
         </p:nvSpPr>
         <p:spPr>
           <a:xfrm>
-            <a:off x="777240" y="4764278"/>
-            <a:ext cx="10607040" cy="256540"/>
+            <a:off x="777240" y="5120640"/>
+            <a:ext cx="10607040" cy="457200"/>
           </a:xfrm>
           <a:prstGeom prst="rect">
             <a:avLst/>
@@ -4820,8 +4853,8 @@
           <a:noFill/>
         </p:spPr>
         <p:txBody>
-          <a:bodyPr wrap="square" lIns="25400" rIns="25400" tIns="12700" bIns="12700">
-            <a:noAutofit/>
+          <a:bodyPr wrap="square" anchor="t" lIns="0" rIns="0" tIns="0" bIns="0">
+            <a:spAutoFit/>
           </a:bodyPr>
           <a:lstStyle/>
           <a:p>
@@ -4829,12 +4862,9 @@
               <a:lnSpc>
                 <a:spcPct val="130000"/>
               </a:lnSpc>
-              <a:spcAft>
-                <a:spcPts val="400"/>
-              </a:spcAft>
             </a:pPr>
             <a:r>
-              <a:rPr sz="1000" b="0">
+              <a:rPr sz="950" b="0" i="0">
                 <a:solidFill>
                   <a:srgbClr val="5C6975"/>
                 </a:solidFill>
@@ -4871,16 +4901,40 @@
         <p:nvPr/>
       </p:nvGrpSpPr>
       <p:grpSpPr/>
-      <p:sp>
-        <p:nvSpPr>
-          <p:cNvPr id="2" name="Rectangle 1"/>
+      <p:pic>
+        <p:nvPicPr>
+          <p:cNvPr id="2" name="Picture 1" descr="bg_motif.png"/>
+          <p:cNvPicPr>
+            <a:picLocks noChangeAspect="1"/>
+          </p:cNvPicPr>
+          <p:nvPr/>
+        </p:nvPicPr>
+        <p:blipFill>
+          <a:blip r:embed="rId2"/>
+          <a:stretch>
+            <a:fillRect/>
+          </a:stretch>
+        </p:blipFill>
+        <p:spPr>
+          <a:xfrm>
+            <a:off x="0" y="0"/>
+            <a:ext cx="12191695" cy="6858000"/>
+          </a:xfrm>
+          <a:prstGeom prst="rect">
+            <a:avLst/>
+          </a:prstGeom>
+        </p:spPr>
+      </p:pic>
+      <p:sp>
+        <p:nvSpPr>
+          <p:cNvPr id="3" name="Rectangle 2"/>
           <p:cNvSpPr/>
           <p:nvPr/>
         </p:nvSpPr>
         <p:spPr>
           <a:xfrm>
             <a:off x="0" y="0"/>
-            <a:ext cx="12191695" cy="38100"/>
+            <a:ext cx="5486400" cy="38100"/>
           </a:xfrm>
           <a:prstGeom prst="rect">
             <a:avLst/>
@@ -4917,14 +4971,14 @@
       </p:sp>
       <p:sp>
         <p:nvSpPr>
-          <p:cNvPr id="3" name="TextBox 2"/>
+          <p:cNvPr id="4" name="TextBox 3"/>
           <p:cNvSpPr txBox="1"/>
           <p:nvPr/>
         </p:nvSpPr>
         <p:spPr>
           <a:xfrm>
-            <a:off x="777240" y="411480"/>
-            <a:ext cx="8686800" cy="365760"/>
+            <a:off x="777240" y="502920"/>
+            <a:ext cx="8229600" cy="320040"/>
           </a:xfrm>
           <a:prstGeom prst="rect">
             <a:avLst/>
@@ -4932,21 +4986,18 @@
           <a:noFill/>
         </p:spPr>
         <p:txBody>
-          <a:bodyPr wrap="square" lIns="25400" rIns="25400" tIns="12700" bIns="12700">
-            <a:noAutofit/>
+          <a:bodyPr wrap="square" anchor="t" lIns="0" rIns="0" tIns="0" bIns="0">
+            <a:spAutoFit/>
           </a:bodyPr>
           <a:lstStyle/>
           <a:p>
             <a:pPr algn="l">
               <a:lnSpc>
-                <a:spcPct val="128000"/>
+                <a:spcPct val="100000"/>
               </a:lnSpc>
-              <a:spcAft>
-                <a:spcPts val="400"/>
-              </a:spcAft>
             </a:pPr>
             <a:r>
-              <a:rPr sz="1100" b="1">
+              <a:rPr sz="1100" b="1" i="0">
                 <a:solidFill>
                   <a:srgbClr val="E7AC51"/>
                 </a:solidFill>
@@ -4959,14 +5010,14 @@
       </p:sp>
       <p:sp>
         <p:nvSpPr>
-          <p:cNvPr id="4" name="TextBox 3"/>
+          <p:cNvPr id="5" name="TextBox 4"/>
           <p:cNvSpPr txBox="1"/>
           <p:nvPr/>
         </p:nvSpPr>
         <p:spPr>
           <a:xfrm>
-            <a:off x="777240" y="2124964"/>
-            <a:ext cx="5989320" cy="904240"/>
+            <a:off x="777240" y="1371600"/>
+            <a:ext cx="5852160" cy="1280160"/>
           </a:xfrm>
           <a:prstGeom prst="rect">
             <a:avLst/>
@@ -4974,21 +5025,18 @@
           <a:noFill/>
         </p:spPr>
         <p:txBody>
-          <a:bodyPr wrap="square" lIns="25400" rIns="25400" tIns="12700" bIns="12700">
-            <a:noAutofit/>
+          <a:bodyPr wrap="square" anchor="t" lIns="0" rIns="0" tIns="0" bIns="0">
+            <a:spAutoFit/>
           </a:bodyPr>
           <a:lstStyle/>
           <a:p>
             <a:pPr algn="l">
               <a:lnSpc>
-                <a:spcPct val="106000"/>
+                <a:spcPct val="112000"/>
               </a:lnSpc>
-              <a:spcAft>
-                <a:spcPts val="400"/>
-              </a:spcAft>
             </a:pPr>
             <a:r>
-              <a:rPr sz="2600" b="0">
+              <a:rPr sz="2400" b="1" i="0">
                 <a:solidFill>
                   <a:srgbClr val="ECEFF3"/>
                 </a:solidFill>
@@ -4997,7 +5045,7 @@
               <a:t>Where they still fall short — </a:t>
             </a:r>
             <a:r>
-              <a:rPr sz="2600" b="0">
+              <a:rPr sz="2400" b="1" i="0">
                 <a:solidFill>
                   <a:srgbClr val="E7AC51"/>
                 </a:solidFill>
@@ -5010,14 +5058,14 @@
       </p:sp>
       <p:sp>
         <p:nvSpPr>
-          <p:cNvPr id="5" name="TextBox 4"/>
+          <p:cNvPr id="6" name="TextBox 5"/>
           <p:cNvSpPr txBox="1"/>
           <p:nvPr/>
         </p:nvSpPr>
         <p:spPr>
           <a:xfrm>
-            <a:off x="777240" y="3029204"/>
-            <a:ext cx="5989320" cy="1029208"/>
+            <a:off x="777240" y="2834640"/>
+            <a:ext cx="5852160" cy="2743200"/>
           </a:xfrm>
           <a:prstGeom prst="rect">
             <a:avLst/>
@@ -5025,21 +5073,18 @@
           <a:noFill/>
         </p:spPr>
         <p:txBody>
-          <a:bodyPr wrap="square" lIns="25400" rIns="25400" tIns="12700" bIns="12700">
-            <a:noAutofit/>
+          <a:bodyPr wrap="square" anchor="t" lIns="0" rIns="0" tIns="0" bIns="0">
+            <a:spAutoFit/>
           </a:bodyPr>
           <a:lstStyle/>
           <a:p>
             <a:pPr algn="l">
               <a:lnSpc>
-                <a:spcPct val="128000"/>
+                <a:spcPct val="145000"/>
               </a:lnSpc>
-              <a:spcAft>
-                <a:spcPts val="400"/>
-              </a:spcAft>
             </a:pPr>
             <a:r>
-              <a:rPr sz="1400" b="0">
+              <a:rPr sz="1400" b="0" i="0">
                 <a:solidFill>
                   <a:srgbClr val="9DA9B5"/>
                 </a:solidFill>
@@ -5048,7 +5093,7 @@
               <a:t>Their strength is </a:t>
             </a:r>
             <a:r>
-              <a:rPr sz="1400" b="1">
+              <a:rPr sz="1400" b="1" i="0">
                 <a:solidFill>
                   <a:srgbClr val="ECEFF3"/>
                 </a:solidFill>
@@ -5057,7 +5102,7 @@
               <a:t>text, not image content.</a:t>
             </a:r>
             <a:r>
-              <a:rPr sz="1400" b="0">
+              <a:rPr sz="1400" b="0" i="0">
                 <a:solidFill>
                   <a:srgbClr val="9DA9B5"/>
                 </a:solidFill>
@@ -5066,7 +5111,7 @@
               <a:t> On radiology interpretation, general VLM diagnostic accuracy ranges only </a:t>
             </a:r>
             <a:r>
-              <a:rPr sz="1400" b="1">
+              <a:rPr sz="1400" b="1" i="0">
                 <a:solidFill>
                   <a:srgbClr val="ECEFF3"/>
                 </a:solidFill>
@@ -5075,7 +5120,7 @@
               <a:t>~8–29%</a:t>
             </a:r>
             <a:r>
-              <a:rPr sz="1400" b="0">
+              <a:rPr sz="1400" b="0" i="0">
                 <a:solidFill>
                   <a:srgbClr val="9DA9B5"/>
                 </a:solidFill>
@@ -5084,7 +5129,7 @@
               <a:t>, and roughly </a:t>
             </a:r>
             <a:r>
-              <a:rPr sz="1400" b="1">
+              <a:rPr sz="1400" b="1" i="0">
                 <a:solidFill>
                   <a:srgbClr val="ECEFF3"/>
                 </a:solidFill>
@@ -5093,27 +5138,54 @@
               <a:t>22%</a:t>
             </a:r>
             <a:r>
-              <a:rPr sz="1400" b="0">
+              <a:rPr sz="1400" b="0" i="0">
                 <a:solidFill>
                   <a:srgbClr val="9DA9B5"/>
                 </a:solidFill>
                 <a:latin typeface="Arial"/>
               </a:rPr>
-              <a:t> of generated reports contain factual errors.</a:t>
-            </a:r>
-          </a:p>
-        </p:txBody>
-      </p:sp>
-      <p:sp>
-        <p:nvSpPr>
-          <p:cNvPr id="6" name="TextBox 5"/>
+              <a:t> of reports contain factual errors. Purpose-built </a:t>
+            </a:r>
+            <a:r>
+              <a:rPr sz="1400" b="1" i="0">
+                <a:solidFill>
+                  <a:srgbClr val="ECEFF3"/>
+                </a:solidFill>
+                <a:latin typeface="Arial"/>
+              </a:rPr>
+              <a:t>RadFM outperforms GPT-4V</a:t>
+            </a:r>
+            <a:r>
+              <a:rPr sz="1400" b="0" i="0">
+                <a:solidFill>
+                  <a:srgbClr val="9DA9B5"/>
+                </a:solidFill>
+                <a:latin typeface="Arial"/>
+              </a:rPr>
+              <a:t>; Med-Gemini-3D CT reports were only </a:t>
+            </a:r>
+            <a:r>
+              <a:rPr sz="1400" b="1" i="0">
+                <a:solidFill>
+                  <a:srgbClr val="ECEFF3"/>
+                </a:solidFill>
+                <a:latin typeface="Arial"/>
+              </a:rPr>
+              <a:t>53% clinically acceptable.</a:t>
+            </a:r>
+          </a:p>
+        </p:txBody>
+      </p:sp>
+      <p:sp>
+        <p:nvSpPr>
+          <p:cNvPr id="7" name="TextBox 6"/>
           <p:cNvSpPr txBox="1"/>
           <p:nvPr/>
         </p:nvSpPr>
         <p:spPr>
           <a:xfrm>
-            <a:off x="777240" y="4058412"/>
-            <a:ext cx="5989320" cy="801623"/>
+            <a:off x="777240" y="6035040"/>
+            <a:ext cx="5852160" cy="457200"/>
           </a:xfrm>
           <a:prstGeom prst="rect">
             <a:avLst/>
@@ -5121,104 +5193,8 @@
           <a:noFill/>
         </p:spPr>
         <p:txBody>
-          <a:bodyPr wrap="square" lIns="25400" rIns="25400" tIns="12700" bIns="12700">
-            <a:noAutofit/>
-          </a:bodyPr>
-          <a:lstStyle/>
-          <a:p>
-            <a:pPr algn="l">
-              <a:lnSpc>
-                <a:spcPct val="128000"/>
-              </a:lnSpc>
-              <a:spcAft>
-                <a:spcPts val="400"/>
-              </a:spcAft>
-            </a:pPr>
-            <a:r>
-              <a:rPr sz="1400" b="0">
-                <a:solidFill>
-                  <a:srgbClr val="9DA9B5"/>
-                </a:solidFill>
-                <a:latin typeface="Arial"/>
-              </a:rPr>
-              <a:t>Purpose-built </a:t>
-            </a:r>
-            <a:r>
-              <a:rPr sz="1400" b="1">
-                <a:solidFill>
-                  <a:srgbClr val="ECEFF3"/>
-                </a:solidFill>
-                <a:latin typeface="Arial"/>
-              </a:rPr>
-              <a:t>RadFM outperforms GPT-4V</a:t>
-            </a:r>
-            <a:r>
-              <a:rPr sz="1400" b="0">
-                <a:solidFill>
-                  <a:srgbClr val="9DA9B5"/>
-                </a:solidFill>
-                <a:latin typeface="Arial"/>
-              </a:rPr>
-              <a:t> on radiology tasks. And 3D lags: Med-Gemini-</a:t>
-            </a:r>
-            <a:r>
-              <a:rPr sz="1400" b="1">
-                <a:solidFill>
-                  <a:srgbClr val="ECEFF3"/>
-                </a:solidFill>
-                <a:latin typeface="Arial"/>
-              </a:rPr>
-              <a:t>3D</a:t>
-            </a:r>
-            <a:r>
-              <a:rPr sz="1400" b="0">
-                <a:solidFill>
-                  <a:srgbClr val="9DA9B5"/>
-                </a:solidFill>
-                <a:latin typeface="Arial"/>
-              </a:rPr>
-              <a:t> CT reports were only </a:t>
-            </a:r>
-            <a:r>
-              <a:rPr sz="1400" b="1">
-                <a:solidFill>
-                  <a:srgbClr val="ECEFF3"/>
-                </a:solidFill>
-                <a:latin typeface="Arial"/>
-              </a:rPr>
-              <a:t>53% clinically acceptable</a:t>
-            </a:r>
-            <a:r>
-              <a:rPr sz="1400" b="0">
-                <a:solidFill>
-                  <a:srgbClr val="9DA9B5"/>
-                </a:solidFill>
-                <a:latin typeface="Arial"/>
-              </a:rPr>
-              <a:t> — fine for a 2D film, less so for a volume.</a:t>
-            </a:r>
-          </a:p>
-        </p:txBody>
-      </p:sp>
-      <p:sp>
-        <p:nvSpPr>
-          <p:cNvPr id="7" name="TextBox 6"/>
-          <p:cNvSpPr txBox="1"/>
-          <p:nvPr/>
-        </p:nvSpPr>
-        <p:spPr>
-          <a:xfrm>
-            <a:off x="777240" y="4860036"/>
-            <a:ext cx="5989320" cy="421640"/>
-          </a:xfrm>
-          <a:prstGeom prst="rect">
-            <a:avLst/>
-          </a:prstGeom>
-          <a:noFill/>
-        </p:spPr>
-        <p:txBody>
-          <a:bodyPr wrap="square" lIns="25400" rIns="25400" tIns="12700" bIns="12700">
-            <a:noAutofit/>
+          <a:bodyPr wrap="square" anchor="t" lIns="0" rIns="0" tIns="0" bIns="0">
+            <a:spAutoFit/>
           </a:bodyPr>
           <a:lstStyle/>
           <a:p>
@@ -5226,40 +5202,37 @@
               <a:lnSpc>
                 <a:spcPct val="130000"/>
               </a:lnSpc>
-              <a:spcAft>
-                <a:spcPts val="400"/>
-              </a:spcAft>
             </a:pPr>
             <a:r>
-              <a:rPr sz="1000" b="0">
+              <a:rPr sz="950" b="0" i="0">
                 <a:solidFill>
                   <a:srgbClr val="5C6975"/>
                 </a:solidFill>
                 <a:latin typeface="Consolas"/>
               </a:rPr>
-              <a:t>Visual LLMs in Radiology, Life (MDPI) 2026;16(1):66 (PMID 41598221) · RadFM — Wu et al., Nat Commun 2025 · Med-Gemini, 2024</a:t>
+              <a:t>Visual LLMs in Radiology, Life (MDPI) 2026;16(1):66 · RadFM — Wu et al., Nat Commun 2025 · Med-Gemini, 2024</a:t>
             </a:r>
           </a:p>
         </p:txBody>
       </p:sp>
       <p:pic>
         <p:nvPicPr>
-          <p:cNvPr id="8" name="Picture 7" descr="s_71478afbef.png"/>
+          <p:cNvPr id="8" name="Picture 7" descr="svg_71478afbef.png"/>
           <p:cNvPicPr>
             <a:picLocks noChangeAspect="1"/>
           </p:cNvPicPr>
           <p:nvPr/>
         </p:nvPicPr>
         <p:blipFill>
-          <a:blip r:embed="rId3"/>
+          <a:blip r:embed="rId4"/>
           <a:stretch>
             <a:fillRect/>
           </a:stretch>
         </p:blipFill>
         <p:spPr>
           <a:xfrm>
-            <a:off x="6995160" y="1825625"/>
-            <a:ext cx="4617720" cy="3206750"/>
+            <a:off x="6400800" y="1633220"/>
+            <a:ext cx="5303520" cy="3683000"/>
           </a:xfrm>
           <a:prstGeom prst="rect">
             <a:avLst/>
@@ -5292,16 +5265,40 @@
         <p:nvPr/>
       </p:nvGrpSpPr>
       <p:grpSpPr/>
-      <p:sp>
-        <p:nvSpPr>
-          <p:cNvPr id="2" name="Rectangle 1"/>
+      <p:pic>
+        <p:nvPicPr>
+          <p:cNvPr id="2" name="Picture 1" descr="bg_motif.png"/>
+          <p:cNvPicPr>
+            <a:picLocks noChangeAspect="1"/>
+          </p:cNvPicPr>
+          <p:nvPr/>
+        </p:nvPicPr>
+        <p:blipFill>
+          <a:blip r:embed="rId2"/>
+          <a:stretch>
+            <a:fillRect/>
+          </a:stretch>
+        </p:blipFill>
+        <p:spPr>
+          <a:xfrm>
+            <a:off x="0" y="0"/>
+            <a:ext cx="12191695" cy="6858000"/>
+          </a:xfrm>
+          <a:prstGeom prst="rect">
+            <a:avLst/>
+          </a:prstGeom>
+        </p:spPr>
+      </p:pic>
+      <p:sp>
+        <p:nvSpPr>
+          <p:cNvPr id="3" name="Rectangle 2"/>
           <p:cNvSpPr/>
           <p:nvPr/>
         </p:nvSpPr>
         <p:spPr>
           <a:xfrm>
             <a:off x="0" y="0"/>
-            <a:ext cx="12191695" cy="38100"/>
+            <a:ext cx="5486400" cy="38100"/>
           </a:xfrm>
           <a:prstGeom prst="rect">
             <a:avLst/>
@@ -5338,14 +5335,14 @@
       </p:sp>
       <p:sp>
         <p:nvSpPr>
-          <p:cNvPr id="3" name="TextBox 2"/>
+          <p:cNvPr id="4" name="TextBox 3"/>
           <p:cNvSpPr txBox="1"/>
           <p:nvPr/>
         </p:nvSpPr>
         <p:spPr>
           <a:xfrm>
-            <a:off x="777240" y="411480"/>
-            <a:ext cx="8686800" cy="365760"/>
+            <a:off x="777240" y="502920"/>
+            <a:ext cx="8229600" cy="320040"/>
           </a:xfrm>
           <a:prstGeom prst="rect">
             <a:avLst/>
@@ -5353,21 +5350,18 @@
           <a:noFill/>
         </p:spPr>
         <p:txBody>
-          <a:bodyPr wrap="square" lIns="25400" rIns="25400" tIns="12700" bIns="12700">
-            <a:noAutofit/>
+          <a:bodyPr wrap="square" anchor="t" lIns="0" rIns="0" tIns="0" bIns="0">
+            <a:spAutoFit/>
           </a:bodyPr>
           <a:lstStyle/>
           <a:p>
             <a:pPr algn="l">
               <a:lnSpc>
-                <a:spcPct val="128000"/>
+                <a:spcPct val="100000"/>
               </a:lnSpc>
-              <a:spcAft>
-                <a:spcPts val="400"/>
-              </a:spcAft>
             </a:pPr>
             <a:r>
-              <a:rPr sz="1100" b="1">
+              <a:rPr sz="1100" b="1" i="0">
                 <a:solidFill>
                   <a:srgbClr val="E7AC51"/>
                 </a:solidFill>
@@ -5380,14 +5374,14 @@
       </p:sp>
       <p:sp>
         <p:nvSpPr>
-          <p:cNvPr id="4" name="TextBox 3"/>
+          <p:cNvPr id="5" name="TextBox 4"/>
           <p:cNvSpPr txBox="1"/>
           <p:nvPr/>
         </p:nvSpPr>
         <p:spPr>
           <a:xfrm>
-            <a:off x="777240" y="1724152"/>
-            <a:ext cx="5989320" cy="904240"/>
+            <a:off x="777240" y="1143000"/>
+            <a:ext cx="5760720" cy="1280160"/>
           </a:xfrm>
           <a:prstGeom prst="rect">
             <a:avLst/>
@@ -5395,21 +5389,18 @@
           <a:noFill/>
         </p:spPr>
         <p:txBody>
-          <a:bodyPr wrap="square" lIns="25400" rIns="25400" tIns="12700" bIns="12700">
-            <a:noAutofit/>
+          <a:bodyPr wrap="square" anchor="t" lIns="0" rIns="0" tIns="0" bIns="0">
+            <a:spAutoFit/>
           </a:bodyPr>
           <a:lstStyle/>
           <a:p>
             <a:pPr algn="l">
               <a:lnSpc>
-                <a:spcPct val="106000"/>
+                <a:spcPct val="112000"/>
               </a:lnSpc>
-              <a:spcAft>
-                <a:spcPts val="400"/>
-              </a:spcAft>
             </a:pPr>
             <a:r>
-              <a:rPr sz="2600" b="0">
+              <a:rPr sz="2400" b="1" i="0">
                 <a:solidFill>
                   <a:srgbClr val="ECEFF3"/>
                 </a:solidFill>
@@ -5418,7 +5409,7 @@
               <a:t>Specializing a model </a:t>
             </a:r>
             <a:r>
-              <a:rPr sz="2600" b="0">
+              <a:rPr sz="2400" b="1" i="0">
                 <a:solidFill>
                   <a:srgbClr val="E7AC51"/>
                 </a:solidFill>
@@ -5431,14 +5422,14 @@
       </p:sp>
       <p:sp>
         <p:nvSpPr>
-          <p:cNvPr id="5" name="TextBox 4"/>
+          <p:cNvPr id="6" name="TextBox 5"/>
           <p:cNvSpPr txBox="1"/>
           <p:nvPr/>
         </p:nvSpPr>
         <p:spPr>
           <a:xfrm>
-            <a:off x="777240" y="2628392"/>
-            <a:ext cx="5989320" cy="1029208"/>
+            <a:off x="777240" y="2606040"/>
+            <a:ext cx="5760720" cy="1463040"/>
           </a:xfrm>
           <a:prstGeom prst="rect">
             <a:avLst/>
@@ -5446,21 +5437,18 @@
           <a:noFill/>
         </p:spPr>
         <p:txBody>
-          <a:bodyPr wrap="square" lIns="25400" rIns="25400" tIns="12700" bIns="12700">
-            <a:noAutofit/>
+          <a:bodyPr wrap="square" anchor="t" lIns="0" rIns="0" tIns="0" bIns="0">
+            <a:spAutoFit/>
           </a:bodyPr>
           <a:lstStyle/>
           <a:p>
             <a:pPr algn="l">
               <a:lnSpc>
-                <a:spcPct val="128000"/>
+                <a:spcPct val="140000"/>
               </a:lnSpc>
-              <a:spcAft>
-                <a:spcPts val="400"/>
-              </a:spcAft>
             </a:pPr>
             <a:r>
-              <a:rPr sz="1400" b="0">
+              <a:rPr sz="1350" b="0" i="0">
                 <a:solidFill>
                   <a:srgbClr val="9DA9B5"/>
                 </a:solidFill>
@@ -5469,7 +5457,7 @@
               <a:t>Medical hallucination is not one failure but many — </a:t>
             </a:r>
             <a:r>
-              <a:rPr sz="1400" b="1">
+              <a:rPr sz="1350" b="1" i="0">
                 <a:solidFill>
                   <a:srgbClr val="ECEFF3"/>
                 </a:solidFill>
@@ -5478,7 +5466,7 @@
               <a:t>factual errors, outdated references, spurious correlations, fabricated sources, and broken chains of reasoning</a:t>
             </a:r>
             <a:r>
-              <a:rPr sz="1400" b="0">
+              <a:rPr sz="1350" b="0" i="0">
                 <a:solidFill>
                   <a:srgbClr val="9DA9B5"/>
                 </a:solidFill>
@@ -5491,14 +5479,14 @@
       </p:sp>
       <p:sp>
         <p:nvSpPr>
-          <p:cNvPr id="6" name="TextBox 5"/>
+          <p:cNvPr id="7" name="TextBox 6"/>
           <p:cNvSpPr txBox="1"/>
           <p:nvPr/>
         </p:nvSpPr>
         <p:spPr>
           <a:xfrm>
-            <a:off x="777240" y="3657600"/>
-            <a:ext cx="5989320" cy="1029208"/>
+            <a:off x="777240" y="4069080"/>
+            <a:ext cx="5760720" cy="1645920"/>
           </a:xfrm>
           <a:prstGeom prst="rect">
             <a:avLst/>
@@ -5506,21 +5494,18 @@
           <a:noFill/>
         </p:spPr>
         <p:txBody>
-          <a:bodyPr wrap="square" lIns="25400" rIns="25400" tIns="12700" bIns="12700">
-            <a:noAutofit/>
+          <a:bodyPr wrap="square" anchor="t" lIns="0" rIns="0" tIns="0" bIns="0">
+            <a:spAutoFit/>
           </a:bodyPr>
           <a:lstStyle/>
           <a:p>
             <a:pPr algn="l">
               <a:lnSpc>
-                <a:spcPct val="128000"/>
+                <a:spcPct val="140000"/>
               </a:lnSpc>
-              <a:spcAft>
-                <a:spcPts val="400"/>
-              </a:spcAft>
             </a:pPr>
             <a:r>
-              <a:rPr sz="1400" b="0">
+              <a:rPr sz="1350" b="0" i="0">
                 <a:solidFill>
                   <a:srgbClr val="9DA9B5"/>
                 </a:solidFill>
@@ -5529,7 +5514,7 @@
               <a:t>On a hallucination benchmark (</a:t>
             </a:r>
             <a:r>
-              <a:rPr sz="1400" b="1">
+              <a:rPr sz="1350" b="1" i="0">
                 <a:solidFill>
                   <a:srgbClr val="ECEFF3"/>
                 </a:solidFill>
@@ -5538,63 +5523,72 @@
               <a:t>Med-HALT, 2025</a:t>
             </a:r>
             <a:r>
-              <a:rPr sz="1400" b="0">
+              <a:rPr sz="1350" b="0" i="0">
                 <a:solidFill>
                   <a:srgbClr val="9DA9B5"/>
                 </a:solidFill>
                 <a:latin typeface="Arial"/>
               </a:rPr>
-              <a:t>), general-purpose models were hallucination-free </a:t>
-            </a:r>
-            <a:r>
-              <a:rPr sz="1400" b="1">
+              <a:t>), general models were hallucination-free </a:t>
+            </a:r>
+            <a:r>
+              <a:rPr sz="1350" b="1" i="0">
+                <a:solidFill>
+                  <a:srgbClr val="E7AC51"/>
+                </a:solidFill>
+                <a:latin typeface="Arial"/>
+              </a:rPr>
+              <a:t>76.6%</a:t>
+            </a:r>
+            <a:r>
+              <a:rPr sz="1350" b="0" i="0">
+                <a:solidFill>
+                  <a:srgbClr val="9DA9B5"/>
+                </a:solidFill>
+                <a:latin typeface="Arial"/>
+              </a:rPr>
+              <a:t> of the time vs only </a:t>
+            </a:r>
+            <a:r>
+              <a:rPr sz="1350" b="1" i="0">
+                <a:solidFill>
+                  <a:srgbClr val="D9785B"/>
+                </a:solidFill>
+                <a:latin typeface="Arial"/>
+              </a:rPr>
+              <a:t>51.3%</a:t>
+            </a:r>
+            <a:r>
+              <a:rPr sz="1350" b="0" i="0">
+                <a:solidFill>
+                  <a:srgbClr val="9DA9B5"/>
+                </a:solidFill>
+                <a:latin typeface="Arial"/>
+              </a:rPr>
+              <a:t> for "specialized" models. The instinct to </a:t>
+            </a:r>
+            <a:r>
+              <a:rPr sz="1350" b="1" i="0">
                 <a:solidFill>
                   <a:srgbClr val="ECEFF3"/>
                 </a:solidFill>
                 <a:latin typeface="Arial"/>
               </a:rPr>
-              <a:t>76.6%</a:t>
-            </a:r>
-            <a:r>
-              <a:rPr sz="1400" b="0">
-                <a:solidFill>
-                  <a:srgbClr val="9DA9B5"/>
-                </a:solidFill>
-                <a:latin typeface="Arial"/>
-              </a:rPr>
-              <a:t> of the time, versus only </a:t>
-            </a:r>
-            <a:r>
-              <a:rPr sz="1400" b="1">
-                <a:solidFill>
-                  <a:srgbClr val="ECEFF3"/>
-                </a:solidFill>
-                <a:latin typeface="Arial"/>
-              </a:rPr>
-              <a:t>51.3%</a:t>
-            </a:r>
-            <a:r>
-              <a:rPr sz="1400" b="0">
-                <a:solidFill>
-                  <a:srgbClr val="9DA9B5"/>
-                </a:solidFill>
-                <a:latin typeface="Arial"/>
-              </a:rPr>
-              <a:t> for medically "specialized" models. Narrowing a model can erode its calibration.</a:t>
-            </a:r>
-          </a:p>
-        </p:txBody>
-      </p:sp>
-      <p:sp>
-        <p:nvSpPr>
-          <p:cNvPr id="7" name="TextBox 6"/>
+              <a:t>buy the medical one may be wrong.</a:t>
+            </a:r>
+          </a:p>
+        </p:txBody>
+      </p:sp>
+      <p:sp>
+        <p:nvSpPr>
+          <p:cNvPr id="8" name="TextBox 7"/>
           <p:cNvSpPr txBox="1"/>
           <p:nvPr/>
         </p:nvSpPr>
         <p:spPr>
           <a:xfrm>
-            <a:off x="777240" y="4686808"/>
-            <a:ext cx="5989320" cy="574040"/>
+            <a:off x="777240" y="6035040"/>
+            <a:ext cx="5760720" cy="457200"/>
           </a:xfrm>
           <a:prstGeom prst="rect">
             <a:avLst/>
@@ -5602,59 +5596,8 @@
           <a:noFill/>
         </p:spPr>
         <p:txBody>
-          <a:bodyPr wrap="square" lIns="25400" rIns="25400" tIns="12700" bIns="12700">
-            <a:noAutofit/>
-          </a:bodyPr>
-          <a:lstStyle/>
-          <a:p>
-            <a:pPr algn="l">
-              <a:lnSpc>
-                <a:spcPct val="128000"/>
-              </a:lnSpc>
-              <a:spcAft>
-                <a:spcPts val="400"/>
-              </a:spcAft>
-            </a:pPr>
-            <a:r>
-              <a:rPr sz="1400" b="0">
-                <a:solidFill>
-                  <a:srgbClr val="9DA9B5"/>
-                </a:solidFill>
-                <a:latin typeface="Arial"/>
-              </a:rPr>
-              <a:t>The specialist-versus-generalist question is unsettled — the instinct to </a:t>
-            </a:r>
-            <a:r>
-              <a:rPr sz="1400" b="1">
-                <a:solidFill>
-                  <a:srgbClr val="ECEFF3"/>
-                </a:solidFill>
-                <a:latin typeface="Arial"/>
-              </a:rPr>
-              <a:t>buy the medical one may be wrong.</a:t>
-            </a:r>
-          </a:p>
-        </p:txBody>
-      </p:sp>
-      <p:sp>
-        <p:nvSpPr>
-          <p:cNvPr id="8" name="TextBox 7"/>
-          <p:cNvSpPr txBox="1"/>
-          <p:nvPr/>
-        </p:nvSpPr>
-        <p:spPr>
-          <a:xfrm>
-            <a:off x="777240" y="5260848"/>
-            <a:ext cx="5989320" cy="421640"/>
-          </a:xfrm>
-          <a:prstGeom prst="rect">
-            <a:avLst/>
-          </a:prstGeom>
-          <a:noFill/>
-        </p:spPr>
-        <p:txBody>
-          <a:bodyPr wrap="square" lIns="25400" rIns="25400" tIns="12700" bIns="12700">
-            <a:noAutofit/>
+          <a:bodyPr wrap="square" anchor="t" lIns="0" rIns="0" tIns="0" bIns="0">
+            <a:spAutoFit/>
           </a:bodyPr>
           <a:lstStyle/>
           <a:p>
@@ -5662,18 +5605,15 @@
               <a:lnSpc>
                 <a:spcPct val="130000"/>
               </a:lnSpc>
-              <a:spcAft>
-                <a:spcPts val="400"/>
-              </a:spcAft>
             </a:pPr>
             <a:r>
-              <a:rPr sz="1000" b="0">
+              <a:rPr sz="950" b="0" i="0">
                 <a:solidFill>
                   <a:srgbClr val="5C6975"/>
                 </a:solidFill>
                 <a:latin typeface="Consolas"/>
               </a:rPr>
-              <a:t>Taxonomy: Kim, Jeong et al., "Medical Hallucination in Foundation Models," arXiv 2503.05777 (2025) · Med-HALT, arXiv 2307.15343</a:t>
+              <a:t>Taxonomy: Kim, Jeong et al., "Medical Hallucination in Foundation Models," arXiv:2503.05777 · Med-HALT, arXiv:2307.15343</a:t>
             </a:r>
           </a:p>
         </p:txBody>
@@ -5686,8 +5626,8 @@
         </p:nvSpPr>
         <p:spPr>
           <a:xfrm>
-            <a:off x="6912864" y="1037844"/>
-            <a:ext cx="4782312" cy="4782312"/>
+            <a:off x="6675120" y="1188719"/>
+            <a:ext cx="4754880" cy="4754880"/>
           </a:xfrm>
           <a:prstGeom prst="roundRect">
             <a:avLst/>
@@ -5726,22 +5666,22 @@
       </p:sp>
       <p:pic>
         <p:nvPicPr>
-          <p:cNvPr id="10" name="Picture 9" descr="i_5f52a8ba52.png"/>
+          <p:cNvPr id="10" name="Picture 9" descr="img_5f52a8ba52.png"/>
           <p:cNvPicPr>
             <a:picLocks noChangeAspect="1"/>
           </p:cNvPicPr>
           <p:nvPr/>
         </p:nvPicPr>
         <p:blipFill>
-          <a:blip r:embed="rId3"/>
+          <a:blip r:embed="rId4"/>
           <a:stretch>
             <a:fillRect/>
           </a:stretch>
         </p:blipFill>
         <p:spPr>
           <a:xfrm>
-            <a:off x="6995160" y="1120140"/>
-            <a:ext cx="4617720" cy="4617720"/>
+            <a:off x="6766560" y="1280160"/>
+            <a:ext cx="4572000" cy="4572000"/>
           </a:xfrm>
           <a:prstGeom prst="rect">
             <a:avLst/>
@@ -5774,16 +5714,40 @@
         <p:nvPr/>
       </p:nvGrpSpPr>
       <p:grpSpPr/>
-      <p:sp>
-        <p:nvSpPr>
-          <p:cNvPr id="2" name="Rectangle 1"/>
+      <p:pic>
+        <p:nvPicPr>
+          <p:cNvPr id="2" name="Picture 1" descr="bg_motif.png"/>
+          <p:cNvPicPr>
+            <a:picLocks noChangeAspect="1"/>
+          </p:cNvPicPr>
+          <p:nvPr/>
+        </p:nvPicPr>
+        <p:blipFill>
+          <a:blip r:embed="rId2"/>
+          <a:stretch>
+            <a:fillRect/>
+          </a:stretch>
+        </p:blipFill>
+        <p:spPr>
+          <a:xfrm>
+            <a:off x="0" y="0"/>
+            <a:ext cx="12191695" cy="6858000"/>
+          </a:xfrm>
+          <a:prstGeom prst="rect">
+            <a:avLst/>
+          </a:prstGeom>
+        </p:spPr>
+      </p:pic>
+      <p:sp>
+        <p:nvSpPr>
+          <p:cNvPr id="3" name="Rectangle 2"/>
           <p:cNvSpPr/>
           <p:nvPr/>
         </p:nvSpPr>
         <p:spPr>
           <a:xfrm>
             <a:off x="0" y="0"/>
-            <a:ext cx="12191695" cy="38100"/>
+            <a:ext cx="5486400" cy="38100"/>
           </a:xfrm>
           <a:prstGeom prst="rect">
             <a:avLst/>
@@ -5820,14 +5784,14 @@
       </p:sp>
       <p:sp>
         <p:nvSpPr>
-          <p:cNvPr id="3" name="TextBox 2"/>
+          <p:cNvPr id="4" name="TextBox 3"/>
           <p:cNvSpPr txBox="1"/>
           <p:nvPr/>
         </p:nvSpPr>
         <p:spPr>
           <a:xfrm>
-            <a:off x="777240" y="411480"/>
-            <a:ext cx="8686800" cy="365760"/>
+            <a:off x="777240" y="502920"/>
+            <a:ext cx="8229600" cy="320040"/>
           </a:xfrm>
           <a:prstGeom prst="rect">
             <a:avLst/>
@@ -5835,21 +5799,18 @@
           <a:noFill/>
         </p:spPr>
         <p:txBody>
-          <a:bodyPr wrap="square" lIns="25400" rIns="25400" tIns="12700" bIns="12700">
-            <a:noAutofit/>
+          <a:bodyPr wrap="square" anchor="t" lIns="0" rIns="0" tIns="0" bIns="0">
+            <a:spAutoFit/>
           </a:bodyPr>
           <a:lstStyle/>
           <a:p>
             <a:pPr algn="l">
               <a:lnSpc>
-                <a:spcPct val="128000"/>
+                <a:spcPct val="100000"/>
               </a:lnSpc>
-              <a:spcAft>
-                <a:spcPts val="400"/>
-              </a:spcAft>
             </a:pPr>
             <a:r>
-              <a:rPr sz="1100" b="1">
+              <a:rPr sz="1100" b="1" i="0">
                 <a:solidFill>
                   <a:srgbClr val="E7AC51"/>
                 </a:solidFill>
@@ -5862,14 +5823,14 @@
       </p:sp>
       <p:sp>
         <p:nvSpPr>
-          <p:cNvPr id="4" name="TextBox 3"/>
+          <p:cNvPr id="5" name="TextBox 4"/>
           <p:cNvSpPr txBox="1"/>
           <p:nvPr/>
         </p:nvSpPr>
         <p:spPr>
           <a:xfrm>
-            <a:off x="777240" y="2448687"/>
-            <a:ext cx="10607040" cy="591312"/>
+            <a:off x="777240" y="1554480"/>
+            <a:ext cx="10607040" cy="1280160"/>
           </a:xfrm>
           <a:prstGeom prst="rect">
             <a:avLst/>
@@ -5877,21 +5838,18 @@
           <a:noFill/>
         </p:spPr>
         <p:txBody>
-          <a:bodyPr wrap="square" lIns="25400" rIns="25400" tIns="12700" bIns="12700">
-            <a:noAutofit/>
+          <a:bodyPr wrap="square" anchor="t" lIns="0" rIns="0" tIns="0" bIns="0">
+            <a:spAutoFit/>
           </a:bodyPr>
           <a:lstStyle/>
           <a:p>
             <a:pPr algn="l">
               <a:lnSpc>
-                <a:spcPct val="106000"/>
+                <a:spcPct val="112000"/>
               </a:lnSpc>
-              <a:spcAft>
-                <a:spcPts val="400"/>
-              </a:spcAft>
             </a:pPr>
             <a:r>
-              <a:rPr sz="3000" b="0">
+              <a:rPr sz="3000" b="1" i="0">
                 <a:solidFill>
                   <a:srgbClr val="ECEFF3"/>
                 </a:solidFill>
@@ -5900,7 +5858,7 @@
               <a:t>The thesis: </a:t>
             </a:r>
             <a:r>
-              <a:rPr sz="3000" b="0">
+              <a:rPr sz="3000" b="1" i="0">
                 <a:solidFill>
                   <a:srgbClr val="E7AC51"/>
                 </a:solidFill>
@@ -5913,14 +5871,58 @@
       </p:sp>
       <p:sp>
         <p:nvSpPr>
-          <p:cNvPr id="5" name="TextBox 4"/>
+          <p:cNvPr id="6" name="Rectangle 5"/>
+          <p:cNvSpPr/>
+          <p:nvPr/>
+        </p:nvSpPr>
+        <p:spPr>
+          <a:xfrm>
+            <a:off x="777240" y="2743200"/>
+            <a:ext cx="27432" cy="1005840"/>
+          </a:xfrm>
+          <a:prstGeom prst="rect">
+            <a:avLst/>
+          </a:prstGeom>
+          <a:solidFill>
+            <a:srgbClr val="E7AC51"/>
+          </a:solidFill>
+          <a:ln>
+            <a:noFill/>
+          </a:ln>
+          <a:effectLst/>
+        </p:spPr>
+        <p:style>
+          <a:lnRef idx="1">
+            <a:schemeClr val="accent1"/>
+          </a:lnRef>
+          <a:fillRef idx="3">
+            <a:schemeClr val="accent1"/>
+          </a:fillRef>
+          <a:effectRef idx="2">
+            <a:schemeClr val="accent1"/>
+          </a:effectRef>
+          <a:fontRef idx="minor">
+            <a:schemeClr val="lt1"/>
+          </a:fontRef>
+        </p:style>
+        <p:txBody>
+          <a:bodyPr rtlCol="0" anchor="ctr"/>
+          <a:lstStyle/>
+          <a:p>
+            <a:pPr algn="ctr"/>
+          </a:p>
+        </p:txBody>
+      </p:sp>
+      <p:sp>
+        <p:nvSpPr>
+          <p:cNvPr id="7" name="TextBox 6"/>
           <p:cNvSpPr txBox="1"/>
           <p:nvPr/>
         </p:nvSpPr>
         <p:spPr>
           <a:xfrm>
-            <a:off x="777240" y="3039998"/>
-            <a:ext cx="10607040" cy="1087374"/>
+            <a:off x="978408" y="2743200"/>
+            <a:ext cx="9857232" cy="1005840"/>
           </a:xfrm>
           <a:prstGeom prst="rect">
             <a:avLst/>
@@ -5928,8 +5930,113 @@
           <a:noFill/>
         </p:spPr>
         <p:txBody>
-          <a:bodyPr wrap="square" lIns="25400" rIns="25400" tIns="12700" bIns="12700">
-            <a:noAutofit/>
+          <a:bodyPr wrap="square" anchor="t" lIns="0" rIns="0" tIns="0" bIns="0">
+            <a:spAutoFit/>
+          </a:bodyPr>
+          <a:lstStyle/>
+          <a:p>
+            <a:pPr algn="l">
+              <a:lnSpc>
+                <a:spcPct val="140000"/>
+              </a:lnSpc>
+            </a:pPr>
+            <a:r>
+              <a:rPr sz="1600" b="0" i="0">
+                <a:solidFill>
+                  <a:srgbClr val="9DA9B5"/>
+                </a:solidFill>
+                <a:latin typeface="Arial"/>
+              </a:rPr>
+              <a:t>Over decades, </a:t>
+            </a:r>
+            <a:r>
+              <a:rPr sz="1600" b="1" i="0">
+                <a:solidFill>
+                  <a:srgbClr val="ECEFF3"/>
+                </a:solidFill>
+                <a:latin typeface="Arial"/>
+              </a:rPr>
+              <a:t>general methods that scale with data and compute</a:t>
+            </a:r>
+            <a:r>
+              <a:rPr sz="1600" b="0" i="0">
+                <a:solidFill>
+                  <a:srgbClr val="9DA9B5"/>
+                </a:solidFill>
+                <a:latin typeface="Arial"/>
+              </a:rPr>
+              <a:t> have repeatedly outperformed systems built on handcrafted domain knowledge — in chess, in vision, in language.</a:t>
+            </a:r>
+          </a:p>
+        </p:txBody>
+      </p:sp>
+      <p:sp>
+        <p:nvSpPr>
+          <p:cNvPr id="8" name="TextBox 7"/>
+          <p:cNvSpPr txBox="1"/>
+          <p:nvPr/>
+        </p:nvSpPr>
+        <p:spPr>
+          <a:xfrm>
+            <a:off x="777240" y="4114800"/>
+            <a:ext cx="10424160" cy="1463040"/>
+          </a:xfrm>
+          <a:prstGeom prst="rect">
+            <a:avLst/>
+          </a:prstGeom>
+          <a:noFill/>
+        </p:spPr>
+        <p:txBody>
+          <a:bodyPr wrap="square" anchor="t" lIns="0" rIns="0" tIns="0" bIns="0">
+            <a:spAutoFit/>
+          </a:bodyPr>
+          <a:lstStyle/>
+          <a:p>
+            <a:pPr algn="l">
+              <a:lnSpc>
+                <a:spcPct val="145000"/>
+              </a:lnSpc>
+            </a:pPr>
+            <a:r>
+              <a:rPr sz="1500" b="0" i="0">
+                <a:solidFill>
+                  <a:srgbClr val="9DA9B5"/>
+                </a:solidFill>
+                <a:latin typeface="Arial"/>
+              </a:rPr>
+              <a:t>Radiology AI has spent fifteen years handcrafting. The trajectory of other fields suggests the generalists eventually take over perception too. </a:t>
+            </a:r>
+            <a:r>
+              <a:rPr sz="1500" b="1" i="0">
+                <a:solidFill>
+                  <a:srgbClr val="ECEFF3"/>
+                </a:solidFill>
+                <a:latin typeface="Arial"/>
+              </a:rPr>
+              <a:t>The open question is when — and what we build in the meantime.</a:t>
+            </a:r>
+          </a:p>
+        </p:txBody>
+      </p:sp>
+      <p:sp>
+        <p:nvSpPr>
+          <p:cNvPr id="9" name="TextBox 8"/>
+          <p:cNvSpPr txBox="1"/>
+          <p:nvPr/>
+        </p:nvSpPr>
+        <p:spPr>
+          <a:xfrm>
+            <a:off x="777240" y="5669280"/>
+            <a:ext cx="10607040" cy="457200"/>
+          </a:xfrm>
+          <a:prstGeom prst="rect">
+            <a:avLst/>
+          </a:prstGeom>
+          <a:noFill/>
+        </p:spPr>
+        <p:txBody>
+          <a:bodyPr wrap="square" anchor="t" lIns="0" rIns="0" tIns="0" bIns="0">
+            <a:spAutoFit/>
           </a:bodyPr>
           <a:lstStyle/>
           <a:p>
@@ -5937,123 +6044,9 @@
               <a:lnSpc>
                 <a:spcPct val="130000"/>
               </a:lnSpc>
-              <a:spcAft>
-                <a:spcPts val="400"/>
-              </a:spcAft>
             </a:pPr>
             <a:r>
-              <a:rPr sz="1900" b="0">
-                <a:solidFill>
-                  <a:srgbClr val="ECEFF3"/>
-                </a:solidFill>
-                <a:latin typeface="Arial"/>
-              </a:rPr>
-              <a:t>Over decades, </a:t>
-            </a:r>
-            <a:r>
-              <a:rPr sz="1900" b="1">
-                <a:solidFill>
-                  <a:srgbClr val="ECEFF3"/>
-                </a:solidFill>
-                <a:latin typeface="Arial"/>
-              </a:rPr>
-              <a:t>general methods that scale with data and compute</a:t>
-            </a:r>
-            <a:r>
-              <a:rPr sz="1900" b="0">
-                <a:solidFill>
-                  <a:srgbClr val="ECEFF3"/>
-                </a:solidFill>
-                <a:latin typeface="Arial"/>
-              </a:rPr>
-              <a:t> have repeatedly outperformed systems built on handcrafted domain knowledge — in chess, in vision, in language.</a:t>
-            </a:r>
-          </a:p>
-        </p:txBody>
-      </p:sp>
-      <p:sp>
-        <p:nvSpPr>
-          <p:cNvPr id="6" name="TextBox 5"/>
-          <p:cNvSpPr txBox="1"/>
-          <p:nvPr/>
-        </p:nvSpPr>
-        <p:spPr>
-          <a:xfrm>
-            <a:off x="777240" y="4127373"/>
-            <a:ext cx="10607040" cy="574040"/>
-          </a:xfrm>
-          <a:prstGeom prst="rect">
-            <a:avLst/>
-          </a:prstGeom>
-          <a:noFill/>
-        </p:spPr>
-        <p:txBody>
-          <a:bodyPr wrap="square" lIns="25400" rIns="25400" tIns="12700" bIns="12700">
-            <a:noAutofit/>
-          </a:bodyPr>
-          <a:lstStyle/>
-          <a:p>
-            <a:pPr algn="l">
-              <a:lnSpc>
-                <a:spcPct val="128000"/>
-              </a:lnSpc>
-              <a:spcAft>
-                <a:spcPts val="400"/>
-              </a:spcAft>
-            </a:pPr>
-            <a:r>
-              <a:rPr sz="1400" b="0">
-                <a:solidFill>
-                  <a:srgbClr val="9DA9B5"/>
-                </a:solidFill>
-                <a:latin typeface="Arial"/>
-              </a:rPr>
-              <a:t>Radiology AI has spent fifteen years handcrafting. The trajectory of other fields suggests the generalists eventually take over perception too. </a:t>
-            </a:r>
-            <a:r>
-              <a:rPr sz="1400" b="1">
-                <a:solidFill>
-                  <a:srgbClr val="ECEFF3"/>
-                </a:solidFill>
-                <a:latin typeface="Arial"/>
-              </a:rPr>
-              <a:t>The open question is when — and what we build in the meantime.</a:t>
-            </a:r>
-          </a:p>
-        </p:txBody>
-      </p:sp>
-      <p:sp>
-        <p:nvSpPr>
-          <p:cNvPr id="7" name="TextBox 6"/>
-          <p:cNvSpPr txBox="1"/>
-          <p:nvPr/>
-        </p:nvSpPr>
-        <p:spPr>
-          <a:xfrm>
-            <a:off x="777240" y="4701413"/>
-            <a:ext cx="10607040" cy="256540"/>
-          </a:xfrm>
-          <a:prstGeom prst="rect">
-            <a:avLst/>
-          </a:prstGeom>
-          <a:noFill/>
-        </p:spPr>
-        <p:txBody>
-          <a:bodyPr wrap="square" lIns="25400" rIns="25400" tIns="12700" bIns="12700">
-            <a:noAutofit/>
-          </a:bodyPr>
-          <a:lstStyle/>
-          <a:p>
-            <a:pPr algn="l">
-              <a:lnSpc>
-                <a:spcPct val="130000"/>
-              </a:lnSpc>
-              <a:spcAft>
-                <a:spcPts val="400"/>
-              </a:spcAft>
-            </a:pPr>
-            <a:r>
-              <a:rPr sz="1000" b="0">
+              <a:rPr sz="950" b="0" i="0">
                 <a:solidFill>
                   <a:srgbClr val="5C6975"/>
                 </a:solidFill>
@@ -6090,16 +6083,40 @@
         <p:nvPr/>
       </p:nvGrpSpPr>
       <p:grpSpPr/>
-      <p:sp>
-        <p:nvSpPr>
-          <p:cNvPr id="2" name="Rectangle 1"/>
+      <p:pic>
+        <p:nvPicPr>
+          <p:cNvPr id="2" name="Picture 1" descr="bg_motif.png"/>
+          <p:cNvPicPr>
+            <a:picLocks noChangeAspect="1"/>
+          </p:cNvPicPr>
+          <p:nvPr/>
+        </p:nvPicPr>
+        <p:blipFill>
+          <a:blip r:embed="rId2"/>
+          <a:stretch>
+            <a:fillRect/>
+          </a:stretch>
+        </p:blipFill>
+        <p:spPr>
+          <a:xfrm>
+            <a:off x="0" y="0"/>
+            <a:ext cx="12191695" cy="6858000"/>
+          </a:xfrm>
+          <a:prstGeom prst="rect">
+            <a:avLst/>
+          </a:prstGeom>
+        </p:spPr>
+      </p:pic>
+      <p:sp>
+        <p:nvSpPr>
+          <p:cNvPr id="3" name="Rectangle 2"/>
           <p:cNvSpPr/>
           <p:nvPr/>
         </p:nvSpPr>
         <p:spPr>
           <a:xfrm>
             <a:off x="0" y="0"/>
-            <a:ext cx="12191695" cy="38100"/>
+            <a:ext cx="5486400" cy="38100"/>
           </a:xfrm>
           <a:prstGeom prst="rect">
             <a:avLst/>
@@ -6136,14 +6153,14 @@
       </p:sp>
       <p:sp>
         <p:nvSpPr>
-          <p:cNvPr id="3" name="TextBox 2"/>
+          <p:cNvPr id="4" name="TextBox 3"/>
           <p:cNvSpPr txBox="1"/>
           <p:nvPr/>
         </p:nvSpPr>
         <p:spPr>
           <a:xfrm>
-            <a:off x="777240" y="411480"/>
-            <a:ext cx="8686800" cy="365760"/>
+            <a:off x="777240" y="502920"/>
+            <a:ext cx="8229600" cy="320040"/>
           </a:xfrm>
           <a:prstGeom prst="rect">
             <a:avLst/>
@@ -6151,21 +6168,18 @@
           <a:noFill/>
         </p:spPr>
         <p:txBody>
-          <a:bodyPr wrap="square" lIns="25400" rIns="25400" tIns="12700" bIns="12700">
-            <a:noAutofit/>
+          <a:bodyPr wrap="square" anchor="t" lIns="0" rIns="0" tIns="0" bIns="0">
+            <a:spAutoFit/>
           </a:bodyPr>
           <a:lstStyle/>
           <a:p>
             <a:pPr algn="l">
               <a:lnSpc>
-                <a:spcPct val="128000"/>
+                <a:spcPct val="100000"/>
               </a:lnSpc>
-              <a:spcAft>
-                <a:spcPts val="400"/>
-              </a:spcAft>
             </a:pPr>
             <a:r>
-              <a:rPr sz="1100" b="1">
+              <a:rPr sz="1100" b="1" i="0">
                 <a:solidFill>
                   <a:srgbClr val="E7AC51"/>
                 </a:solidFill>
@@ -6178,14 +6192,14 @@
       </p:sp>
       <p:sp>
         <p:nvSpPr>
-          <p:cNvPr id="4" name="TextBox 3"/>
+          <p:cNvPr id="5" name="TextBox 4"/>
           <p:cNvSpPr txBox="1"/>
           <p:nvPr/>
         </p:nvSpPr>
         <p:spPr>
           <a:xfrm>
-            <a:off x="777240" y="2336800"/>
-            <a:ext cx="10607040" cy="534416"/>
+            <a:off x="777240" y="1234440"/>
+            <a:ext cx="10058400" cy="1280160"/>
           </a:xfrm>
           <a:prstGeom prst="rect">
             <a:avLst/>
@@ -6193,21 +6207,18 @@
           <a:noFill/>
         </p:spPr>
         <p:txBody>
-          <a:bodyPr wrap="square" lIns="25400" rIns="25400" tIns="12700" bIns="12700">
-            <a:noAutofit/>
+          <a:bodyPr wrap="square" anchor="t" lIns="0" rIns="0" tIns="0" bIns="0">
+            <a:spAutoFit/>
           </a:bodyPr>
           <a:lstStyle/>
           <a:p>
             <a:pPr algn="l">
               <a:lnSpc>
-                <a:spcPct val="106000"/>
+                <a:spcPct val="112000"/>
               </a:lnSpc>
-              <a:spcAft>
-                <a:spcPts val="400"/>
-              </a:spcAft>
             </a:pPr>
             <a:r>
-              <a:rPr sz="2600" b="0">
+              <a:rPr sz="2700" b="1" i="0">
                 <a:solidFill>
                   <a:srgbClr val="ECEFF3"/>
                 </a:solidFill>
@@ -6216,7 +6227,7 @@
               <a:t>A likely answer: </a:t>
             </a:r>
             <a:r>
-              <a:rPr sz="2600" b="0">
+              <a:rPr sz="2700" b="1" i="0">
                 <a:solidFill>
                   <a:srgbClr val="E7AC51"/>
                 </a:solidFill>
@@ -6229,14 +6240,14 @@
       </p:sp>
       <p:sp>
         <p:nvSpPr>
-          <p:cNvPr id="5" name="TextBox 4"/>
+          <p:cNvPr id="6" name="TextBox 5"/>
           <p:cNvSpPr txBox="1"/>
           <p:nvPr/>
         </p:nvSpPr>
         <p:spPr>
           <a:xfrm>
-            <a:off x="777240" y="2871215"/>
-            <a:ext cx="10607040" cy="801623"/>
+            <a:off x="777240" y="2468880"/>
+            <a:ext cx="10424160" cy="1645920"/>
           </a:xfrm>
           <a:prstGeom prst="rect">
             <a:avLst/>
@@ -6244,21 +6255,18 @@
           <a:noFill/>
         </p:spPr>
         <p:txBody>
-          <a:bodyPr wrap="square" lIns="25400" rIns="25400" tIns="12700" bIns="12700">
-            <a:noAutofit/>
+          <a:bodyPr wrap="square" anchor="t" lIns="0" rIns="0" tIns="0" bIns="0">
+            <a:spAutoFit/>
           </a:bodyPr>
           <a:lstStyle/>
           <a:p>
             <a:pPr algn="l">
               <a:lnSpc>
-                <a:spcPct val="128000"/>
+                <a:spcPct val="145000"/>
               </a:lnSpc>
-              <a:spcAft>
-                <a:spcPts val="400"/>
-              </a:spcAft>
             </a:pPr>
             <a:r>
-              <a:rPr sz="1400" b="0">
+              <a:rPr sz="1500" b="0" i="0">
                 <a:solidFill>
                   <a:srgbClr val="9DA9B5"/>
                 </a:solidFill>
@@ -6267,7 +6275,7 @@
               <a:t>The probable future is a </a:t>
             </a:r>
             <a:r>
-              <a:rPr sz="1400" b="1">
+              <a:rPr sz="1500" b="1" i="0">
                 <a:solidFill>
                   <a:srgbClr val="ECEFF3"/>
                 </a:solidFill>
@@ -6276,7 +6284,7 @@
               <a:t>stack</a:t>
             </a:r>
             <a:r>
-              <a:rPr sz="1400" b="0">
+              <a:rPr sz="1500" b="0" i="0">
                 <a:solidFill>
                   <a:srgbClr val="9DA9B5"/>
                 </a:solidFill>
@@ -6285,7 +6293,7 @@
               <a:t>, not a replacement. A </a:t>
             </a:r>
             <a:r>
-              <a:rPr sz="1400" b="1">
+              <a:rPr sz="1500" b="1" i="0">
                 <a:solidFill>
                   <a:srgbClr val="ECEFF3"/>
                 </a:solidFill>
@@ -6294,7 +6302,7 @@
               <a:t>frontier model as the reasoning and orchestration layer</a:t>
             </a:r>
             <a:r>
-              <a:rPr sz="1400" b="0">
+              <a:rPr sz="1500" b="0" i="0">
                 <a:solidFill>
                   <a:srgbClr val="9DA9B5"/>
                 </a:solidFill>
@@ -6303,7 +6311,7 @@
               <a:t> — it reads the EHR, talks to the patient, writes the report, decides the next step — calling </a:t>
             </a:r>
             <a:r>
-              <a:rPr sz="1400" b="1">
+              <a:rPr sz="1500" b="1" i="0">
                 <a:solidFill>
                   <a:srgbClr val="ECEFF3"/>
                 </a:solidFill>
@@ -6312,7 +6320,7 @@
               <a:t>specialist models as instruments:</a:t>
             </a:r>
             <a:r>
-              <a:rPr sz="1400" b="0">
+              <a:rPr sz="1500" b="0" i="0">
                 <a:solidFill>
                   <a:srgbClr val="9DA9B5"/>
                 </a:solidFill>
@@ -6325,14 +6333,14 @@
       </p:sp>
       <p:sp>
         <p:nvSpPr>
-          <p:cNvPr id="6" name="Rounded Rectangle 5"/>
+          <p:cNvPr id="7" name="Rounded Rectangle 6"/>
           <p:cNvSpPr/>
           <p:nvPr/>
         </p:nvSpPr>
         <p:spPr>
           <a:xfrm>
-            <a:off x="777240" y="3672840"/>
-            <a:ext cx="3508121" cy="365760"/>
+            <a:off x="777240" y="4343400"/>
+            <a:ext cx="3375781" cy="384048"/>
           </a:xfrm>
           <a:prstGeom prst="roundRect">
             <a:avLst/>
@@ -6342,7 +6350,7 @@
           </a:solidFill>
           <a:ln w="9525">
             <a:solidFill>
-              <a:srgbClr val="2A333E"/>
+              <a:srgbClr val="2A333D"/>
             </a:solidFill>
           </a:ln>
           <a:effectLst/>
@@ -6362,12 +6370,16 @@
           </a:fontRef>
         </p:style>
         <p:txBody>
-          <a:bodyPr rtlCol="0" anchor="ctr" wrap="none" lIns="109728" rIns="73152" tIns="0" bIns="0"/>
-          <a:lstStyle/>
-          <a:p>
-            <a:pPr algn="ctr"/>
-            <a:r>
-              <a:rPr sz="1100">
+          <a:bodyPr rtlCol="0" anchor="ctr" wrap="none" lIns="137160" tIns="0" bIns="0"/>
+          <a:lstStyle/>
+          <a:p>
+            <a:pPr algn="l">
+              <a:lnSpc>
+                <a:spcPct val="100000"/>
+              </a:lnSpc>
+            </a:pPr>
+            <a:r>
+              <a:rPr sz="1050" b="0" i="0">
                 <a:solidFill>
                   <a:srgbClr val="ECEFF3"/>
                 </a:solidFill>
@@ -6380,14 +6392,14 @@
       </p:sp>
       <p:sp>
         <p:nvSpPr>
-          <p:cNvPr id="7" name="Rectangle 6"/>
+          <p:cNvPr id="8" name="Rectangle 7"/>
           <p:cNvSpPr/>
           <p:nvPr/>
         </p:nvSpPr>
         <p:spPr>
           <a:xfrm>
-            <a:off x="777240" y="3672840"/>
-            <a:ext cx="36576" cy="365760"/>
+            <a:off x="777240" y="4343400"/>
+            <a:ext cx="41148" cy="384048"/>
           </a:xfrm>
           <a:prstGeom prst="rect">
             <a:avLst/>
@@ -6424,14 +6436,14 @@
       </p:sp>
       <p:sp>
         <p:nvSpPr>
-          <p:cNvPr id="8" name="Rounded Rectangle 7"/>
+          <p:cNvPr id="9" name="Rounded Rectangle 8"/>
           <p:cNvSpPr/>
           <p:nvPr/>
         </p:nvSpPr>
         <p:spPr>
           <a:xfrm>
-            <a:off x="4376801" y="3672840"/>
-            <a:ext cx="3508121" cy="365760"/>
+            <a:off x="4299325" y="4343400"/>
+            <a:ext cx="3375781" cy="384048"/>
           </a:xfrm>
           <a:prstGeom prst="roundRect">
             <a:avLst/>
@@ -6441,7 +6453,7 @@
           </a:solidFill>
           <a:ln w="9525">
             <a:solidFill>
-              <a:srgbClr val="2A333E"/>
+              <a:srgbClr val="2A333D"/>
             </a:solidFill>
           </a:ln>
           <a:effectLst/>
@@ -6461,12 +6473,16 @@
           </a:fontRef>
         </p:style>
         <p:txBody>
-          <a:bodyPr rtlCol="0" anchor="ctr" wrap="none" lIns="109728" rIns="73152" tIns="0" bIns="0"/>
-          <a:lstStyle/>
-          <a:p>
-            <a:pPr algn="ctr"/>
-            <a:r>
-              <a:rPr sz="1100">
+          <a:bodyPr rtlCol="0" anchor="ctr" wrap="none" lIns="137160" tIns="0" bIns="0"/>
+          <a:lstStyle/>
+          <a:p>
+            <a:pPr algn="l">
+              <a:lnSpc>
+                <a:spcPct val="100000"/>
+              </a:lnSpc>
+            </a:pPr>
+            <a:r>
+              <a:rPr sz="1050" b="0" i="0">
                 <a:solidFill>
                   <a:srgbClr val="ECEFF3"/>
                 </a:solidFill>
@@ -6479,14 +6495,14 @@
       </p:sp>
       <p:sp>
         <p:nvSpPr>
-          <p:cNvPr id="9" name="Rectangle 8"/>
+          <p:cNvPr id="10" name="Rectangle 9"/>
           <p:cNvSpPr/>
           <p:nvPr/>
         </p:nvSpPr>
         <p:spPr>
           <a:xfrm>
-            <a:off x="4376801" y="3672840"/>
-            <a:ext cx="36576" cy="365760"/>
+            <a:off x="4299325" y="4343400"/>
+            <a:ext cx="41148" cy="384048"/>
           </a:xfrm>
           <a:prstGeom prst="rect">
             <a:avLst/>
@@ -6523,14 +6539,14 @@
       </p:sp>
       <p:sp>
         <p:nvSpPr>
-          <p:cNvPr id="10" name="Rounded Rectangle 9"/>
+          <p:cNvPr id="11" name="Rounded Rectangle 10"/>
           <p:cNvSpPr/>
           <p:nvPr/>
         </p:nvSpPr>
         <p:spPr>
           <a:xfrm>
-            <a:off x="777240" y="4111752"/>
-            <a:ext cx="3676395" cy="365760"/>
+            <a:off x="7821411" y="4343400"/>
+            <a:ext cx="3533241" cy="384048"/>
           </a:xfrm>
           <a:prstGeom prst="roundRect">
             <a:avLst/>
@@ -6540,7 +6556,7 @@
           </a:solidFill>
           <a:ln w="9525">
             <a:solidFill>
-              <a:srgbClr val="2A333E"/>
+              <a:srgbClr val="2A333D"/>
             </a:solidFill>
           </a:ln>
           <a:effectLst/>
@@ -6560,12 +6576,16 @@
           </a:fontRef>
         </p:style>
         <p:txBody>
-          <a:bodyPr rtlCol="0" anchor="ctr" wrap="none" lIns="109728" rIns="73152" tIns="0" bIns="0"/>
-          <a:lstStyle/>
-          <a:p>
-            <a:pPr algn="ctr"/>
-            <a:r>
-              <a:rPr sz="1100">
+          <a:bodyPr rtlCol="0" anchor="ctr" wrap="none" lIns="137160" tIns="0" bIns="0"/>
+          <a:lstStyle/>
+          <a:p>
+            <a:pPr algn="l">
+              <a:lnSpc>
+                <a:spcPct val="100000"/>
+              </a:lnSpc>
+            </a:pPr>
+            <a:r>
+              <a:rPr sz="1050" b="0" i="0">
                 <a:solidFill>
                   <a:srgbClr val="ECEFF3"/>
                 </a:solidFill>
@@ -6574,21 +6594,21 @@
               <a:t>increasingly </a:t>
             </a:r>
             <a:r>
-              <a:rPr sz="1100">
+              <a:rPr sz="1050" b="1" i="0">
+                <a:solidFill>
+                  <a:srgbClr val="5FB7C9"/>
+                </a:solidFill>
+                <a:latin typeface="Consolas"/>
+              </a:rPr>
+              <a:t>domain-adapted</a:t>
+            </a:r>
+            <a:r>
+              <a:rPr sz="1050" b="0" i="0">
                 <a:solidFill>
                   <a:srgbClr val="ECEFF3"/>
                 </a:solidFill>
                 <a:latin typeface="Consolas"/>
               </a:rPr>
-              <a:t>domain-adapted</a:t>
-            </a:r>
-            <a:r>
-              <a:rPr sz="1100">
-                <a:solidFill>
-                  <a:srgbClr val="ECEFF3"/>
-                </a:solidFill>
-                <a:latin typeface="Consolas"/>
-              </a:rPr>
               <a:t> (Med-Gemini)</a:t>
             </a:r>
           </a:p>
@@ -6596,14 +6616,14 @@
       </p:sp>
       <p:sp>
         <p:nvSpPr>
-          <p:cNvPr id="11" name="Rectangle 10"/>
+          <p:cNvPr id="12" name="Rectangle 11"/>
           <p:cNvSpPr/>
           <p:nvPr/>
         </p:nvSpPr>
         <p:spPr>
           <a:xfrm>
-            <a:off x="777240" y="4111752"/>
-            <a:ext cx="36576" cy="365760"/>
+            <a:off x="7821411" y="4343400"/>
+            <a:ext cx="41148" cy="384048"/>
           </a:xfrm>
           <a:prstGeom prst="rect">
             <a:avLst/>
@@ -6640,14 +6660,14 @@
       </p:sp>
       <p:sp>
         <p:nvSpPr>
-          <p:cNvPr id="12" name="TextBox 11"/>
+          <p:cNvPr id="13" name="TextBox 12"/>
           <p:cNvSpPr txBox="1"/>
           <p:nvPr/>
         </p:nvSpPr>
         <p:spPr>
           <a:xfrm>
-            <a:off x="777240" y="4605528"/>
-            <a:ext cx="10607040" cy="574040"/>
+            <a:off x="777240" y="5166360"/>
+            <a:ext cx="10424160" cy="731520"/>
           </a:xfrm>
           <a:prstGeom prst="rect">
             <a:avLst/>
@@ -6655,21 +6675,18 @@
           <a:noFill/>
         </p:spPr>
         <p:txBody>
-          <a:bodyPr wrap="square" lIns="25400" rIns="25400" tIns="12700" bIns="12700">
-            <a:noAutofit/>
+          <a:bodyPr wrap="square" anchor="t" lIns="0" rIns="0" tIns="0" bIns="0">
+            <a:spAutoFit/>
           </a:bodyPr>
           <a:lstStyle/>
           <a:p>
             <a:pPr algn="l">
               <a:lnSpc>
-                <a:spcPct val="128000"/>
+                <a:spcPct val="140000"/>
               </a:lnSpc>
-              <a:spcAft>
-                <a:spcPts val="400"/>
-              </a:spcAft>
             </a:pPr>
             <a:r>
-              <a:rPr sz="1400" b="0">
+              <a:rPr sz="1300" b="0" i="0">
                 <a:solidFill>
                   <a:srgbClr val="9DA9B5"/>
                 </a:solidFill>
@@ -6706,16 +6723,40 @@
         <p:nvPr/>
       </p:nvGrpSpPr>
       <p:grpSpPr/>
-      <p:sp>
-        <p:nvSpPr>
-          <p:cNvPr id="2" name="Rectangle 1"/>
+      <p:pic>
+        <p:nvPicPr>
+          <p:cNvPr id="2" name="Picture 1" descr="bg_motif.png"/>
+          <p:cNvPicPr>
+            <a:picLocks noChangeAspect="1"/>
+          </p:cNvPicPr>
+          <p:nvPr/>
+        </p:nvPicPr>
+        <p:blipFill>
+          <a:blip r:embed="rId2"/>
+          <a:stretch>
+            <a:fillRect/>
+          </a:stretch>
+        </p:blipFill>
+        <p:spPr>
+          <a:xfrm>
+            <a:off x="0" y="0"/>
+            <a:ext cx="12191695" cy="6858000"/>
+          </a:xfrm>
+          <a:prstGeom prst="rect">
+            <a:avLst/>
+          </a:prstGeom>
+        </p:spPr>
+      </p:pic>
+      <p:sp>
+        <p:nvSpPr>
+          <p:cNvPr id="3" name="Rectangle 2"/>
           <p:cNvSpPr/>
           <p:nvPr/>
         </p:nvSpPr>
         <p:spPr>
           <a:xfrm>
             <a:off x="0" y="0"/>
-            <a:ext cx="12191695" cy="38100"/>
+            <a:ext cx="5486400" cy="38100"/>
           </a:xfrm>
           <a:prstGeom prst="rect">
             <a:avLst/>
@@ -6752,14 +6793,14 @@
       </p:sp>
       <p:sp>
         <p:nvSpPr>
-          <p:cNvPr id="3" name="TextBox 2"/>
+          <p:cNvPr id="4" name="TextBox 3"/>
           <p:cNvSpPr txBox="1"/>
           <p:nvPr/>
         </p:nvSpPr>
         <p:spPr>
           <a:xfrm>
-            <a:off x="777240" y="411480"/>
-            <a:ext cx="8686800" cy="365760"/>
+            <a:off x="777240" y="502920"/>
+            <a:ext cx="8229600" cy="320040"/>
           </a:xfrm>
           <a:prstGeom prst="rect">
             <a:avLst/>
@@ -6767,21 +6808,18 @@
           <a:noFill/>
         </p:spPr>
         <p:txBody>
-          <a:bodyPr wrap="square" lIns="25400" rIns="25400" tIns="12700" bIns="12700">
-            <a:noAutofit/>
+          <a:bodyPr wrap="square" anchor="t" lIns="0" rIns="0" tIns="0" bIns="0">
+            <a:spAutoFit/>
           </a:bodyPr>
           <a:lstStyle/>
           <a:p>
             <a:pPr algn="l">
               <a:lnSpc>
-                <a:spcPct val="128000"/>
+                <a:spcPct val="100000"/>
               </a:lnSpc>
-              <a:spcAft>
-                <a:spcPts val="400"/>
-              </a:spcAft>
             </a:pPr>
             <a:r>
-              <a:rPr sz="1100" b="1">
+              <a:rPr sz="1100" b="1" i="0">
                 <a:solidFill>
                   <a:srgbClr val="E7AC51"/>
                 </a:solidFill>
@@ -6794,14 +6832,14 @@
       </p:sp>
       <p:sp>
         <p:nvSpPr>
-          <p:cNvPr id="4" name="TextBox 3"/>
+          <p:cNvPr id="5" name="TextBox 4"/>
           <p:cNvSpPr txBox="1"/>
           <p:nvPr/>
         </p:nvSpPr>
         <p:spPr>
           <a:xfrm>
-            <a:off x="777240" y="2141346"/>
-            <a:ext cx="10607040" cy="591312"/>
+            <a:off x="777240" y="1280160"/>
+            <a:ext cx="10607040" cy="1280160"/>
           </a:xfrm>
           <a:prstGeom prst="rect">
             <a:avLst/>
@@ -6809,21 +6847,18 @@
           <a:noFill/>
         </p:spPr>
         <p:txBody>
-          <a:bodyPr wrap="square" lIns="25400" rIns="25400" tIns="12700" bIns="12700">
-            <a:noAutofit/>
+          <a:bodyPr wrap="square" anchor="t" lIns="0" rIns="0" tIns="0" bIns="0">
+            <a:spAutoFit/>
           </a:bodyPr>
           <a:lstStyle/>
           <a:p>
             <a:pPr algn="l">
               <a:lnSpc>
-                <a:spcPct val="106000"/>
+                <a:spcPct val="112000"/>
               </a:lnSpc>
-              <a:spcAft>
-                <a:spcPts val="400"/>
-              </a:spcAft>
             </a:pPr>
             <a:r>
-              <a:rPr sz="3000" b="0">
+              <a:rPr sz="3000" b="1" i="0">
                 <a:solidFill>
                   <a:srgbClr val="ECEFF3"/>
                 </a:solidFill>
@@ -6832,7 +6867,7 @@
               <a:t>What it means </a:t>
             </a:r>
             <a:r>
-              <a:rPr sz="3000" b="0">
+              <a:rPr sz="3000" b="1" i="0">
                 <a:solidFill>
                   <a:srgbClr val="E7AC51"/>
                 </a:solidFill>
@@ -6845,14 +6880,14 @@
       </p:sp>
       <p:sp>
         <p:nvSpPr>
-          <p:cNvPr id="5" name="Rounded Rectangle 4"/>
+          <p:cNvPr id="6" name="Rounded Rectangle 5"/>
           <p:cNvSpPr/>
           <p:nvPr/>
         </p:nvSpPr>
         <p:spPr>
           <a:xfrm>
-            <a:off x="777240" y="2732658"/>
-            <a:ext cx="5611558" cy="365760"/>
+            <a:off x="777240" y="2743200"/>
+            <a:ext cx="5344027" cy="384048"/>
           </a:xfrm>
           <a:prstGeom prst="roundRect">
             <a:avLst/>
@@ -6862,7 +6897,7 @@
           </a:solidFill>
           <a:ln w="9525">
             <a:solidFill>
-              <a:srgbClr val="2A333E"/>
+              <a:srgbClr val="2A333D"/>
             </a:solidFill>
           </a:ln>
           <a:effectLst/>
@@ -6882,26 +6917,30 @@
           </a:fontRef>
         </p:style>
         <p:txBody>
-          <a:bodyPr rtlCol="0" anchor="ctr" wrap="none" lIns="109728" rIns="73152" tIns="0" bIns="0"/>
-          <a:lstStyle/>
-          <a:p>
-            <a:pPr algn="ctr"/>
-            <a:r>
-              <a:rPr sz="1100">
+          <a:bodyPr rtlCol="0" anchor="ctr" wrap="none" lIns="137160" tIns="0" bIns="0"/>
+          <a:lstStyle/>
+          <a:p>
+            <a:pPr algn="l">
+              <a:lnSpc>
+                <a:spcPct val="100000"/>
+              </a:lnSpc>
+            </a:pPr>
+            <a:r>
+              <a:rPr sz="1050" b="1" i="0">
+                <a:solidFill>
+                  <a:srgbClr val="5FB7C9"/>
+                </a:solidFill>
+                <a:latin typeface="Consolas"/>
+              </a:rPr>
+              <a:t>Value moves</a:t>
+            </a:r>
+            <a:r>
+              <a:rPr sz="1050" b="0" i="0">
                 <a:solidFill>
                   <a:srgbClr val="ECEFF3"/>
                 </a:solidFill>
                 <a:latin typeface="Consolas"/>
               </a:rPr>
-              <a:t>Value moves</a:t>
-            </a:r>
-            <a:r>
-              <a:rPr sz="1100">
-                <a:solidFill>
-                  <a:srgbClr val="ECEFF3"/>
-                </a:solidFill>
-                <a:latin typeface="Consolas"/>
-              </a:rPr>
               <a:t> to data, validation, integration — not architecture</a:t>
             </a:r>
           </a:p>
@@ -6909,14 +6948,14 @@
       </p:sp>
       <p:sp>
         <p:nvSpPr>
-          <p:cNvPr id="6" name="Rectangle 5"/>
+          <p:cNvPr id="7" name="Rectangle 6"/>
           <p:cNvSpPr/>
           <p:nvPr/>
         </p:nvSpPr>
         <p:spPr>
           <a:xfrm>
-            <a:off x="777240" y="2732658"/>
-            <a:ext cx="36576" cy="365760"/>
+            <a:off x="777240" y="2743200"/>
+            <a:ext cx="41148" cy="384048"/>
           </a:xfrm>
           <a:prstGeom prst="rect">
             <a:avLst/>
@@ -6953,14 +6992,14 @@
       </p:sp>
       <p:sp>
         <p:nvSpPr>
-          <p:cNvPr id="7" name="Rounded Rectangle 6"/>
+          <p:cNvPr id="8" name="Rounded Rectangle 7"/>
           <p:cNvSpPr/>
           <p:nvPr/>
         </p:nvSpPr>
         <p:spPr>
           <a:xfrm>
-            <a:off x="777240" y="3171570"/>
-            <a:ext cx="5695696" cy="365760"/>
+            <a:off x="777240" y="3255264"/>
+            <a:ext cx="5422757" cy="384048"/>
           </a:xfrm>
           <a:prstGeom prst="roundRect">
             <a:avLst/>
@@ -6970,7 +7009,7 @@
           </a:solidFill>
           <a:ln w="9525">
             <a:solidFill>
-              <a:srgbClr val="2A333E"/>
+              <a:srgbClr val="2A333D"/>
             </a:solidFill>
           </a:ln>
           <a:effectLst/>
@@ -6990,26 +7029,30 @@
           </a:fontRef>
         </p:style>
         <p:txBody>
-          <a:bodyPr rtlCol="0" anchor="ctr" wrap="none" lIns="109728" rIns="73152" tIns="0" bIns="0"/>
-          <a:lstStyle/>
-          <a:p>
-            <a:pPr algn="ctr"/>
-            <a:r>
-              <a:rPr sz="1100">
+          <a:bodyPr rtlCol="0" anchor="ctr" wrap="none" lIns="137160" tIns="0" bIns="0"/>
+          <a:lstStyle/>
+          <a:p>
+            <a:pPr algn="l">
+              <a:lnSpc>
+                <a:spcPct val="100000"/>
+              </a:lnSpc>
+            </a:pPr>
+            <a:r>
+              <a:rPr sz="1050" b="1" i="0">
+                <a:solidFill>
+                  <a:srgbClr val="5FB7C9"/>
+                </a:solidFill>
+                <a:latin typeface="Consolas"/>
+              </a:rPr>
+              <a:t>Concentration</a:t>
+            </a:r>
+            <a:r>
+              <a:rPr sz="1050" b="0" i="0">
                 <a:solidFill>
                   <a:srgbClr val="ECEFF3"/>
                 </a:solidFill>
                 <a:latin typeface="Consolas"/>
               </a:rPr>
-              <a:t>Concentration</a:t>
-            </a:r>
-            <a:r>
-              <a:rPr sz="1100">
-                <a:solidFill>
-                  <a:srgbClr val="ECEFF3"/>
-                </a:solidFill>
-                <a:latin typeface="Consolas"/>
-              </a:rPr>
               <a:t> is a governance problem: cost, sovereignty, access</a:t>
             </a:r>
           </a:p>
@@ -7017,14 +7060,14 @@
       </p:sp>
       <p:sp>
         <p:nvSpPr>
-          <p:cNvPr id="8" name="Rectangle 7"/>
+          <p:cNvPr id="9" name="Rectangle 8"/>
           <p:cNvSpPr/>
           <p:nvPr/>
         </p:nvSpPr>
         <p:spPr>
           <a:xfrm>
-            <a:off x="777240" y="3171570"/>
-            <a:ext cx="36576" cy="365760"/>
+            <a:off x="777240" y="3255264"/>
+            <a:ext cx="41148" cy="384048"/>
           </a:xfrm>
           <a:prstGeom prst="rect">
             <a:avLst/>
@@ -7061,14 +7104,14 @@
       </p:sp>
       <p:sp>
         <p:nvSpPr>
-          <p:cNvPr id="9" name="Rounded Rectangle 8"/>
+          <p:cNvPr id="10" name="Rounded Rectangle 9"/>
           <p:cNvSpPr/>
           <p:nvPr/>
         </p:nvSpPr>
         <p:spPr>
           <a:xfrm>
-            <a:off x="777240" y="3610482"/>
-            <a:ext cx="4854321" cy="365760"/>
+            <a:off x="777240" y="3383280"/>
+            <a:ext cx="4635459" cy="384048"/>
           </a:xfrm>
           <a:prstGeom prst="roundRect">
             <a:avLst/>
@@ -7078,7 +7121,7 @@
           </a:solidFill>
           <a:ln w="9525">
             <a:solidFill>
-              <a:srgbClr val="2A333E"/>
+              <a:srgbClr val="2A333D"/>
             </a:solidFill>
           </a:ln>
           <a:effectLst/>
@@ -7098,26 +7141,30 @@
           </a:fontRef>
         </p:style>
         <p:txBody>
-          <a:bodyPr rtlCol="0" anchor="ctr" wrap="none" lIns="109728" rIns="73152" tIns="0" bIns="0"/>
-          <a:lstStyle/>
-          <a:p>
-            <a:pPr algn="ctr"/>
-            <a:r>
-              <a:rPr sz="1100">
+          <a:bodyPr rtlCol="0" anchor="ctr" wrap="none" lIns="137160" tIns="0" bIns="0"/>
+          <a:lstStyle/>
+          <a:p>
+            <a:pPr algn="l">
+              <a:lnSpc>
+                <a:spcPct val="100000"/>
+              </a:lnSpc>
+            </a:pPr>
+            <a:r>
+              <a:rPr sz="1050" b="1" i="0">
+                <a:solidFill>
+                  <a:srgbClr val="5FB7C9"/>
+                </a:solidFill>
+                <a:latin typeface="Consolas"/>
+              </a:rPr>
+              <a:t>The radiologist</a:t>
+            </a:r>
+            <a:r>
+              <a:rPr sz="1050" b="0" i="0">
                 <a:solidFill>
                   <a:srgbClr val="ECEFF3"/>
                 </a:solidFill>
                 <a:latin typeface="Consolas"/>
               </a:rPr>
-              <a:t>The radiologist</a:t>
-            </a:r>
-            <a:r>
-              <a:rPr sz="1100">
-                <a:solidFill>
-                  <a:srgbClr val="ECEFF3"/>
-                </a:solidFill>
-                <a:latin typeface="Consolas"/>
-              </a:rPr>
               <a:t> shifts toward validator &amp; orchestrator</a:t>
             </a:r>
           </a:p>
@@ -7125,14 +7172,14 @@
       </p:sp>
       <p:sp>
         <p:nvSpPr>
-          <p:cNvPr id="10" name="Rectangle 9"/>
+          <p:cNvPr id="11" name="Rectangle 10"/>
           <p:cNvSpPr/>
           <p:nvPr/>
         </p:nvSpPr>
         <p:spPr>
           <a:xfrm>
-            <a:off x="777240" y="3610482"/>
-            <a:ext cx="36576" cy="365760"/>
+            <a:off x="777240" y="3383280"/>
+            <a:ext cx="41148" cy="384048"/>
           </a:xfrm>
           <a:prstGeom prst="rect">
             <a:avLst/>
@@ -7169,14 +7216,14 @@
       </p:sp>
       <p:sp>
         <p:nvSpPr>
-          <p:cNvPr id="11" name="TextBox 10"/>
+          <p:cNvPr id="12" name="TextBox 11"/>
           <p:cNvSpPr txBox="1"/>
           <p:nvPr/>
         </p:nvSpPr>
         <p:spPr>
           <a:xfrm>
-            <a:off x="777240" y="4104258"/>
-            <a:ext cx="10607040" cy="1087374"/>
+            <a:off x="777240" y="4251960"/>
+            <a:ext cx="10424160" cy="1463040"/>
           </a:xfrm>
           <a:prstGeom prst="rect">
             <a:avLst/>
@@ -7184,78 +7231,33 @@
           <a:noFill/>
         </p:spPr>
         <p:txBody>
-          <a:bodyPr wrap="square" lIns="25400" rIns="25400" tIns="12700" bIns="12700">
-            <a:noAutofit/>
+          <a:bodyPr wrap="square" anchor="t" lIns="0" rIns="0" tIns="0" bIns="0">
+            <a:spAutoFit/>
           </a:bodyPr>
           <a:lstStyle/>
           <a:p>
             <a:pPr algn="l">
               <a:lnSpc>
-                <a:spcPct val="130000"/>
+                <a:spcPct val="145000"/>
               </a:lnSpc>
-              <a:spcAft>
-                <a:spcPts val="400"/>
-              </a:spcAft>
             </a:pPr>
             <a:r>
-              <a:rPr sz="1900" b="0">
+              <a:rPr sz="1600" b="0" i="0">
+                <a:solidFill>
+                  <a:srgbClr val="9DA9B5"/>
+                </a:solidFill>
+                <a:latin typeface="Arial"/>
+              </a:rPr>
+              <a:t>Whether the result is a specialist model or a frontier generalist, built in Palo Alto or in this room, it does not change what makes it safe. </a:t>
+            </a:r>
+            <a:r>
+              <a:rPr sz="1600" b="1" i="0">
                 <a:solidFill>
                   <a:srgbClr val="ECEFF3"/>
                 </a:solidFill>
                 <a:latin typeface="Arial"/>
               </a:rPr>
-              <a:t>Whether the result is a specialist model or a frontier generalist, built in Palo Alto or in this room, it does not change what makes it safe. </a:t>
-            </a:r>
-            <a:r>
-              <a:rPr sz="1900" b="1">
-                <a:solidFill>
-                  <a:srgbClr val="ECEFF3"/>
-                </a:solidFill>
-                <a:latin typeface="Arial"/>
-              </a:rPr>
               <a:t>The bar is the same one CAD failed and MASAI cleared.</a:t>
-            </a:r>
-          </a:p>
-        </p:txBody>
-      </p:sp>
-      <p:sp>
-        <p:nvSpPr>
-          <p:cNvPr id="12" name="TextBox 11"/>
-          <p:cNvSpPr txBox="1"/>
-          <p:nvPr/>
-        </p:nvSpPr>
-        <p:spPr>
-          <a:xfrm>
-            <a:off x="777240" y="5191633"/>
-            <a:ext cx="10607040" cy="256540"/>
-          </a:xfrm>
-          <a:prstGeom prst="rect">
-            <a:avLst/>
-          </a:prstGeom>
-          <a:noFill/>
-        </p:spPr>
-        <p:txBody>
-          <a:bodyPr wrap="square" lIns="25400" rIns="25400" tIns="12700" bIns="12700">
-            <a:noAutofit/>
-          </a:bodyPr>
-          <a:lstStyle/>
-          <a:p>
-            <a:pPr algn="l">
-              <a:lnSpc>
-                <a:spcPct val="130000"/>
-              </a:lnSpc>
-              <a:spcAft>
-                <a:spcPts val="400"/>
-              </a:spcAft>
-            </a:pPr>
-            <a:r>
-              <a:rPr sz="1000" b="0">
-                <a:solidFill>
-                  <a:srgbClr val="5C6975"/>
-                </a:solidFill>
-                <a:latin typeface="Consolas"/>
-              </a:rPr>
-              <a:t>Connects to §6 equity · bridges to §7 — the close</a:t>
             </a:r>
           </a:p>
         </p:txBody>

</xml_diff>